<commit_message>
Update BeingAReader_Template with T6W2 Varjak Paw (Holly / The Way / Conflict)
</commit_message>
<xml_diff>
--- a/Reading/BeingAReader_Template.pptx
+++ b/Reading/BeingAReader_Template.pptx
@@ -6858,7 +6858,7 @@
                           <a:effectLst/>
                           <a:latin typeface="Calibri" panose="020F0502020204030204" pitchFamily="34" charset="0"/>
                         </a:rPr>
-                        <a:t>relentless</a:t>
+                        <a:t>concentration</a:t>
                       </a:r>
                     </a:p>
                   </a:txBody>
@@ -6917,7 +6917,7 @@
                           <a:effectLst/>
                           <a:latin typeface="Calibri" panose="020F0502020204030204" pitchFamily="34" charset="0"/>
                         </a:rPr>
-                        <a:t>never stopping or giving up; continuing with great force</a:t>
+                        <a:t>giving all your attention and effort to one thing</a:t>
                       </a:r>
                     </a:p>
                   </a:txBody>
@@ -6983,7 +6983,7 @@
                           <a:effectLst/>
                           <a:latin typeface="Calibri" panose="020F0502020204030204" pitchFamily="34" charset="0"/>
                         </a:rPr>
-                        <a:t>instinct</a:t>
+                        <a:t>fierce</a:t>
                       </a:r>
                     </a:p>
                   </a:txBody>
@@ -7042,7 +7042,7 @@
                           <a:effectLst/>
                           <a:latin typeface="Calibri" panose="020F0502020204030204" pitchFamily="34" charset="0"/>
                         </a:rPr>
-                        <a:t>a natural feeling that tells you what to do without thinking</a:t>
+                        <a:t>very strong and intense; powerful</a:t>
                       </a:r>
                     </a:p>
                   </a:txBody>
@@ -7108,7 +7108,7 @@
                           <a:effectLst/>
                           <a:latin typeface="Calibri" panose="020F0502020204030204" pitchFamily="34" charset="0"/>
                         </a:rPr>
-                        <a:t>desperate</a:t>
+                        <a:t>precise</a:t>
                       </a:r>
                     </a:p>
                   </a:txBody>
@@ -7167,7 +7167,7 @@
                           <a:effectLst/>
                           <a:latin typeface="Calibri" panose="020F0502020204030204" pitchFamily="34" charset="0"/>
                         </a:rPr>
-                        <a:t>feeling as though you need something so badly you will do anything</a:t>
+                        <a:t>exact and accurate; done very carefully</a:t>
                       </a:r>
                     </a:p>
                   </a:txBody>
@@ -7233,7 +7233,7 @@
                           <a:effectLst/>
                           <a:latin typeface="Calibri" panose="020F0502020204030204" pitchFamily="34" charset="0"/>
                         </a:rPr>
-                        <a:t>hesitated</a:t>
+                        <a:t>surge</a:t>
                       </a:r>
                     </a:p>
                   </a:txBody>
@@ -7292,7 +7292,7 @@
                           <a:effectLst/>
                           <a:latin typeface="Calibri" panose="020F0502020204030204" pitchFamily="34" charset="0"/>
                         </a:rPr>
-                        <a:t>paused for a moment because you were unsure what to do</a:t>
+                        <a:t>a sudden, powerful rush of feeling or movement</a:t>
                       </a:r>
                     </a:p>
                   </a:txBody>
@@ -7358,7 +7358,7 @@
                           <a:effectLst/>
                           <a:latin typeface="Calibri" panose="020F0502020204030204" pitchFamily="34" charset="0"/>
                         </a:rPr>
-                        <a:t>alert</a:t>
+                        <a:t>composed</a:t>
                       </a:r>
                     </a:p>
                   </a:txBody>
@@ -7417,7 +7417,7 @@
                           <a:effectLst/>
                           <a:latin typeface="Calibri" panose="020F0502020204030204" pitchFamily="34" charset="0"/>
                         </a:rPr>
-                        <a:t>fully awake and paying close attention to everything around you</a:t>
+                        <a:t>calm and in control of your feelings</a:t>
                       </a:r>
                     </a:p>
                   </a:txBody>
@@ -8497,7 +8497,7 @@
                           </a:solidFill>
                           <a:latin typeface="XCCW Joined 4a" panose="03050602040000000000" pitchFamily="66" charset="77"/>
                         </a:rPr>
-                        <a:t>desperate</a:t>
+                        <a:t>fierce</a:t>
                       </a:r>
                     </a:p>
                     <a:p>
@@ -8847,7 +8847,7 @@
             <a:pPr algn="ctr"/>
             <a:r>
               <a:rPr lang="en-GB"/>
-              <a:t>desperate</a:t>
+              <a:t>fierce</a:t>
             </a:r>
           </a:p>
         </p:txBody>
@@ -9511,7 +9511,13 @@
           <a:p>
             <a:r>
               <a:rPr lang="en-US" sz="2200" dirty="0"/>
-              <a:t>The alley was narrow and dark, and Varjak pressed himself against the damp wall, trying to make himself as small as possible. He had heard them before he saw them — two large dogs, moving with a relentless, heavy certainty, their paws thudding against the wet cobblestones. Every instinct Varjak had was screaming at him to run, but he forced himself to stay still. His mentor's words rang in his head: be the stillness at the centre of the storm. He was desperate. He had no food, no shelter and no idea where he was going. The dogs paused at the end of the alley, their heads swinging left and right as they sniffed the cold air. One of them was enormous, with a barrel chest and a low growl that Varjak felt more than heard. He hesitated, uncertain whether to stay hidden or bolt for the gap between the bins ahead. His heart hammered. He forced himself to breathe slowly, to stay alert, to notice every detail the way Jalal's teaching had shown him. The big dog took one step towards the alley. Then another. Varjak's claws bit into the ground. He was ready. But then, without warning, a car horn blared from the road and both dogs flinched and turned away, trotting off into the yellow evening light. Varjak let out a long, shaking breath. He was safe. For now.</a:t>
+              <a:t>The first time Varjak used the Way in the real world, three cats had cornered him against a rusting fence. His heart was hammering. Every part of him wanted to run, but there was nowhere to go.
+So instead, he closed his eyes. He thought of the river in Jalal's teaching — water that did not fight the rocks but moved around them. He let his breathing slow. He felt the ground beneath his paws, solid and real, and he let himself become part of it.
+When he opened his eyes, something had shifted. The fear was still there, but it had moved somewhere quieter. His body felt steady. Composed.
+He moved — not away, but sideways, then through a gap he had not seen before, his body low and precise, each step placed with fierce concentration. The three cats watched, confused. They had expected panic. What they got was something altogether different.
+Varjak did not stop until he was two streets away, his heart still loud in his ears but his paws moving steadily beneath him. He sat down on a doorstep. He breathed.
+"That worked," he said aloud, to nobody.
+And then, slowly, he smiled.</a:t>
             </a:r>
           </a:p>
         </p:txBody>
@@ -16038,13 +16044,13 @@
           <a:p>
             <a:r>
               <a:rPr lang="en-US" sz="1900"/>
-              <a:t>Give two reasons from the text why Varjak is feeling desperate.</a:t>
+              <a:t>Give two details from the text that show the three cats are surprised by Varjak.</a:t>
             </a:r>
           </a:p>
           <a:p>
             <a:r>
               <a:rPr lang="en-US" sz="1900"/>
-              <a:t>Varjak is desperate because he has no food, no shelter and no idea where he is going.</a:t>
+              <a:t>The text says the cats 'watched, confused'. It also says 'they had expected panic' — both show the cats did not expect Varjak to respond the way he did.</a:t>
             </a:r>
           </a:p>
           <a:p>
@@ -16053,13 +16059,13 @@
           <a:p>
             <a:r>
               <a:rPr lang="en-US" sz="1900"/>
-              <a:t>What does Varjak do to try to stay calm when the dogs approach?</a:t>
+              <a:t>What does the word 'composed' mean? How does the context help you work it out?</a:t>
             </a:r>
           </a:p>
           <a:p>
             <a:r>
               <a:rPr lang="en-US" sz="1900"/>
-              <a:t>He forces himself to breathe slowly, stay alert and notice every detail around him, just as Jalal's teaching had shown him.</a:t>
+              <a:t>Composed means calm and in control. The context helps because just before, Varjak's heart was hammering and he wanted to run — so composed shows the opposite of that panic, a new stillness he has found through using the Way.</a:t>
             </a:r>
           </a:p>
         </p:txBody>
@@ -16099,7 +16105,13 @@
           <a:p>
             <a:r>
               <a:rPr lang="en-US" sz="2200"/>
-              <a:t>The alley was narrow and dark, and Varjak pressed himself against the damp wall, trying to make himself as small as possible. He had heard them before he saw them — two large dogs, moving with a relentless, heavy certainty, their paws thudding against the wet cobblestones. Every instinct Varjak had was screaming at him to run, but he forced himself to stay still. His mentor's words rang in his head: be the stillness at the centre of the storm. He was desperate. He had no food, no shelter and no idea where he was going. The dogs paused at the end of the alley, their heads swinging left and right as they sniffed the cold air. One of them was enormous, with a barrel chest and a low growl that Varjak felt more than heard. He hesitated, uncertain whether to stay hidden or bolt for the gap between the bins ahead. His heart hammered. He forced himself to breathe slowly, to stay alert, to notice every detail the way Jalal's teaching had shown him. The big dog took one step towards the alley. Then another. Varjak's claws bit into the ground. He was ready. But then, without warning, a car horn blared from the road and both dogs flinched and turned away, trotting off into the yellow evening light. Varjak let out a long, shaking breath. He was safe. For now.</a:t>
+              <a:t>The first time Varjak used the Way in the real world, three cats had cornered him against a rusting fence. His heart was hammering. Every part of him wanted to run, but there was nowhere to go.
+So instead, he closed his eyes. He thought of the river in Jalal's teaching — water that did not fight the rocks but moved around them. He let his breathing slow. He felt the ground beneath his paws, solid and real, and he let himself become part of it.
+When he opened his eyes, something had shifted. The fear was still there, but it had moved somewhere quieter. His body felt steady. Composed.
+He moved — not away, but sideways, then through a gap he had not seen before, his body low and precise, each step placed with fierce concentration. The three cats watched, confused. They had expected panic. What they got was something altogether different.
+Varjak did not stop until he was two streets away, his heart still loud in his ears but his paws moving steadily beneath him. He sat down on a doorstep. He breathed.
+"That worked," he said aloud, to nobody.
+And then, slowly, he smiled.</a:t>
             </a:r>
           </a:p>
         </p:txBody>
@@ -16745,7 +16757,7 @@
             <a:pPr algn="ctr"/>
             <a:r>
               <a:rPr lang="en-GB" sz="8800" dirty="0"/>
-              <a:t>Friday</a:t>
+              <a:t>Thursday</a:t>
             </a:r>
           </a:p>
         </p:txBody>
@@ -17785,7 +17797,7 @@
                           <a:effectLst/>
                           <a:latin typeface="Calibri" panose="020F0502020204030204" pitchFamily="34" charset="0"/>
                         </a:rPr>
-                        <a:t>yearned</a:t>
+                        <a:t>conflicted</a:t>
                       </a:r>
                     </a:p>
                   </a:txBody>
@@ -17844,7 +17856,7 @@
                           <a:effectLst/>
                           <a:latin typeface="Calibri" panose="020F0502020204030204" pitchFamily="34" charset="0"/>
                         </a:rPr>
-                        <a:t>wanted something deeply and with great feeling, like an ache</a:t>
+                        <a:t>having two opposing feelings or ideas at the same time; torn</a:t>
                       </a:r>
                     </a:p>
                   </a:txBody>
@@ -17910,7 +17922,7 @@
                           <a:effectLst/>
                           <a:latin typeface="Calibri" panose="020F0502020204030204" pitchFamily="34" charset="0"/>
                         </a:rPr>
-                        <a:t>solitary</a:t>
+                        <a:t>burden</a:t>
                       </a:r>
                     </a:p>
                   </a:txBody>
@@ -17969,7 +17981,7 @@
                           <a:effectLst/>
                           <a:latin typeface="Calibri" panose="020F0502020204030204" pitchFamily="34" charset="0"/>
                         </a:rPr>
-                        <a:t>alone, without anyone else around</a:t>
+                        <a:t>a heavy load — either physical or emotional — that you have to carry</a:t>
                       </a:r>
                     </a:p>
                   </a:txBody>
@@ -18035,7 +18047,7 @@
                           <a:effectLst/>
                           <a:latin typeface="Calibri" panose="020F0502020204030204" pitchFamily="34" charset="0"/>
                         </a:rPr>
-                        <a:t>flinched</a:t>
+                        <a:t>worthwhile</a:t>
                       </a:r>
                     </a:p>
                   </a:txBody>
@@ -18094,7 +18106,7 @@
                           <a:effectLst/>
                           <a:latin typeface="Calibri" panose="020F0502020204030204" pitchFamily="34" charset="0"/>
                         </a:rPr>
-                        <a:t>made a small, sharp movement in reaction to pain or a sudden feeling</a:t>
+                        <a:t>important or useful enough to make the effort</a:t>
                       </a:r>
                     </a:p>
                   </a:txBody>
@@ -18160,7 +18172,7 @@
                           <a:effectLst/>
                           <a:latin typeface="Calibri" panose="020F0502020204030204" pitchFamily="34" charset="0"/>
                         </a:rPr>
-                        <a:t>distant</a:t>
+                        <a:t>weary</a:t>
                       </a:r>
                     </a:p>
                   </a:txBody>
@@ -18219,7 +18231,7 @@
                           <a:effectLst/>
                           <a:latin typeface="Calibri" panose="020F0502020204030204" pitchFamily="34" charset="0"/>
                         </a:rPr>
-                        <a:t>far away, either in place or in feeling</a:t>
+                        <a:t>very tired, especially after a long time doing something difficult</a:t>
                       </a:r>
                     </a:p>
                   </a:txBody>
@@ -18285,7 +18297,7 @@
                           <a:effectLst/>
                           <a:latin typeface="Calibri" panose="020F0502020204030204" pitchFamily="34" charset="0"/>
                         </a:rPr>
-                        <a:t>resolve</a:t>
+                        <a:t>stubborn</a:t>
                       </a:r>
                     </a:p>
                   </a:txBody>
@@ -18344,7 +18356,7 @@
                           <a:effectLst/>
                           <a:latin typeface="Calibri" panose="020F0502020204030204" pitchFamily="34" charset="0"/>
                         </a:rPr>
-                        <a:t>a strong, firm decision that you will do something no matter what</a:t>
+                        <a:t>refusing to change your mind or give up, even when things are hard</a:t>
                       </a:r>
                     </a:p>
                   </a:txBody>
@@ -19424,7 +19436,7 @@
                           </a:solidFill>
                           <a:latin typeface="XCCW Joined 4a" panose="03050602040000000000" pitchFamily="66" charset="77"/>
                         </a:rPr>
-                        <a:t>yearned</a:t>
+                        <a:t>conflicted</a:t>
                       </a:r>
                     </a:p>
                     <a:p>
@@ -19774,7 +19786,7 @@
             <a:pPr algn="ctr"/>
             <a:r>
               <a:rPr lang="en-GB"/>
-              <a:t>yearned</a:t>
+              <a:t>conflicted</a:t>
             </a:r>
           </a:p>
         </p:txBody>
@@ -20695,7 +20707,12 @@
           <a:p>
             <a:r>
               <a:rPr lang="en-US" sz="2200" dirty="0"/>
-              <a:t>The city never truly slept. Even in the small hours, when most humans had retreated behind their lit windows, the streets below still hummed and clicked and breathed. Varjak crouched on a fire escape above it all, his tail wrapped around his paws, watching. He was completely alone. He had not eaten properly in two days, and the cold was beginning to bite at the edges of everything. He yearned for the tower with an ache that surprised him — not for the tower itself, exactly, but for the smell of it, the warmth of his brothers pressed close on either side, his mother's voice low and steady in the dark. He flinched at the memory, as though it had edges. Below him, a solitary figure crossed the empty road and disappeared into a doorway. Varjak watched until they were gone. Then he looked up. Above the yellow smear of city light, he could just make out a handful of stars — distant, cold, barely there. His grandfather had spoken of a sky full of stars. The world must have been a different place then, Varjak thought. But the thought did not break him. Instead, something hardened quietly in his chest. He had come too far to go back now. He did not know if he would succeed. He only knew that he would not stop. That resolve, small and solid and certain, was enough for tonight.</a:t>
+              <a:t>The rain had been falling for hours. Varjak sat under the lip of a drainpipe, watching the gutters fill, feeling the cold settle into his bones. He had not found what he was looking for. He had not even come close.
+He thought about home. It came to him in pieces — the smell of warm stone, the weight of his mother's paw on the back of his neck when he was small, the sound of his brothers breathing in the dark. He had carried all of it with him since the moment he left, a burden he had not known he was lifting.
+He could go back. He knew that. Nobody had told him he had to stay. The Way could get him there — he was sure of it now. He could be home by morning, warm and safe, with the family he had not stopped missing for a single day.
+But then he thought of what waited in the tower. The Gentleman. The dark cats. His mother and brothers trapped behind those walls. He thought of Elder Paw's last words to him, weary with age but stubborn as stone: there is only one who can save us now.
+Could he really turn back? Could he live with himself if he did?
+He sat with the question a long time. The rain kept falling. He did not move.</a:t>
             </a:r>
           </a:p>
         </p:txBody>
@@ -27222,13 +27239,13 @@
           <a:p>
             <a:r>
               <a:rPr lang="en-US" sz="1900"/>
-              <a:t>What three things does Varjak miss from the tower?</a:t>
+              <a:t>What three things does Varjak remember about home?</a:t>
             </a:r>
           </a:p>
           <a:p>
             <a:r>
               <a:rPr lang="en-US" sz="1900"/>
-              <a:t>He misses the smell of the tower, the warmth of his brothers pressed close on either side and his mother's voice low and steady in the dark.</a:t>
+              <a:t>He thinks about the smell of warm stone, the weight of his mother's paw on the back of his neck when he was small, and the sound of his brothers breathing in the dark.</a:t>
             </a:r>
           </a:p>
           <a:p>
@@ -27237,13 +27254,13 @@
           <a:p>
             <a:r>
               <a:rPr lang="en-US" sz="1900"/>
-              <a:t>What does the word 'yearned' mean? How does the context help you work this out?</a:t>
+              <a:t>What does the word 'burden' mean? How does the writer use it here?</a:t>
             </a:r>
           </a:p>
           <a:p>
             <a:r>
               <a:rPr lang="en-US" sz="1900"/>
-              <a:t>Yearned means wanting something deeply, like an ache. The text describes it as 'an ache that surprised him', and Varjak is clearly missing his family very much, which tells us the word means a deep, painful kind of longing.</a:t>
+              <a:t>A burden is a heavy load you carry. The writer uses it to describe Varjak's memories of home — precious but exhausting to carry. He describes it as 'a burden he had not known he was lifting', showing the weight of missing home had been there all along without him realising it.</a:t>
             </a:r>
           </a:p>
         </p:txBody>
@@ -27283,7 +27300,12 @@
           <a:p>
             <a:r>
               <a:rPr lang="en-US" sz="2200"/>
-              <a:t>The city never truly slept. Even in the small hours, when most humans had retreated behind their lit windows, the streets below still hummed and clicked and breathed. Varjak crouched on a fire escape above it all, his tail wrapped around his paws, watching. He was completely alone. He had not eaten properly in two days, and the cold was beginning to bite at the edges of everything. He yearned for the tower with an ache that surprised him — not for the tower itself, exactly, but for the smell of it, the warmth of his brothers pressed close on either side, his mother's voice low and steady in the dark. He flinched at the memory, as though it had edges. Below him, a solitary figure crossed the empty road and disappeared into a doorway. Varjak watched until they were gone. Then he looked up. Above the yellow smear of city light, he could just make out a handful of stars — distant, cold, barely there. His grandfather had spoken of a sky full of stars. The world must have been a different place then, Varjak thought. But the thought did not break him. Instead, something hardened quietly in his chest. He had come too far to go back now. He did not know if he would succeed. He only knew that he would not stop. That resolve, small and solid and certain, was enough for tonight.</a:t>
+              <a:t>The rain had been falling for hours. Varjak sat under the lip of a drainpipe, watching the gutters fill, feeling the cold settle into his bones. He had not found what he was looking for. He had not even come close.
+He thought about home. It came to him in pieces — the smell of warm stone, the weight of his mother's paw on the back of his neck when he was small, the sound of his brothers breathing in the dark. He had carried all of it with him since the moment he left, a burden he had not known he was lifting.
+He could go back. He knew that. Nobody had told him he had to stay. The Way could get him there — he was sure of it now. He could be home by morning, warm and safe, with the family he had not stopped missing for a single day.
+But then he thought of what waited in the tower. The Gentleman. The dark cats. His mother and brothers trapped behind those walls. He thought of Elder Paw's last words to him, weary with age but stubborn as stone: there is only one who can save us now.
+Could he really turn back? Could he live with himself if he did?
+He sat with the question a long time. The rain kept falling. He did not move.</a:t>
             </a:r>
           </a:p>
         </p:txBody>
@@ -28672,7 +28694,7 @@
                           <a:effectLst/>
                           <a:latin typeface="Calibri" panose="020F0502020204030204" pitchFamily="34" charset="0"/>
                         </a:rPr>
-                        <a:t>trembling</a:t>
+                        <a:t>suspicious</a:t>
                       </a:r>
                     </a:p>
                   </a:txBody>
@@ -28731,7 +28753,7 @@
                           <a:effectLst/>
                           <a:latin typeface="Calibri" panose="020F0502020204030204" pitchFamily="34" charset="0"/>
                         </a:rPr>
-                        <a:t>shaking slightly because of fear or excitement</a:t>
+                        <a:t>not trusting someone; thinking they might cause trouble</a:t>
                       </a:r>
                     </a:p>
                   </a:txBody>
@@ -28797,7 +28819,7 @@
                           <a:effectLst/>
                           <a:latin typeface="Calibri" panose="020F0502020204030204" pitchFamily="34" charset="0"/>
                         </a:rPr>
-                        <a:t>overwhelmed</a:t>
+                        <a:t>wary</a:t>
                       </a:r>
                     </a:p>
                   </a:txBody>
@@ -28856,7 +28878,7 @@
                           <a:effectLst/>
                           <a:latin typeface="Calibri" panose="020F0502020204030204" pitchFamily="34" charset="0"/>
                         </a:rPr>
-                        <a:t>feeling as though something is too much to cope with</a:t>
+                        <a:t>careful and watchful, not fully trusting a situation or person</a:t>
                       </a:r>
                     </a:p>
                   </a:txBody>
@@ -28922,7 +28944,7 @@
                           <a:effectLst/>
                           <a:latin typeface="Calibri" panose="020F0502020204030204" pitchFamily="34" charset="0"/>
                         </a:rPr>
-                        <a:t>cautiously</a:t>
+                        <a:t>defiant</a:t>
                       </a:r>
                     </a:p>
                   </a:txBody>
@@ -28981,7 +29003,7 @@
                           <a:effectLst/>
                           <a:latin typeface="Calibri" panose="020F0502020204030204" pitchFamily="34" charset="0"/>
                         </a:rPr>
-                        <a:t>carefully, trying to avoid danger or making a mistake</a:t>
+                        <a:t>refusing to obey or be controlled; standing up against something</a:t>
                       </a:r>
                     </a:p>
                   </a:txBody>
@@ -29047,7 +29069,7 @@
                           <a:effectLst/>
                           <a:latin typeface="Calibri" panose="020F0502020204030204" pitchFamily="34" charset="0"/>
                         </a:rPr>
-                        <a:t>horizon</a:t>
+                        <a:t>grudging</a:t>
                       </a:r>
                     </a:p>
                   </a:txBody>
@@ -29106,7 +29128,7 @@
                           <a:effectLst/>
                           <a:latin typeface="Calibri" panose="020F0502020204030204" pitchFamily="34" charset="0"/>
                         </a:rPr>
-                        <a:t>the line in the distance where the sky seems to meet the land</a:t>
+                        <a:t>given unwillingly, without wanting to admit it</a:t>
                       </a:r>
                     </a:p>
                   </a:txBody>
@@ -29172,7 +29194,7 @@
                           <a:effectLst/>
                           <a:latin typeface="Calibri" panose="020F0502020204030204" pitchFamily="34" charset="0"/>
                         </a:rPr>
-                        <a:t>uncertain</a:t>
+                        <a:t>curiosity</a:t>
                       </a:r>
                     </a:p>
                   </a:txBody>
@@ -29231,7 +29253,7 @@
                           <a:effectLst/>
                           <a:latin typeface="Calibri" panose="020F0502020204030204" pitchFamily="34" charset="0"/>
                         </a:rPr>
-                        <a:t>not sure what is going to happen; unsure</a:t>
+                        <a:t>a strong desire to know or find out more about something</a:t>
                       </a:r>
                     </a:p>
                   </a:txBody>
@@ -30318,7 +30340,7 @@
                           </a:solidFill>
                           <a:latin typeface="Twinkl Cursive Looped Light" panose="02000000000000000000" pitchFamily="2" charset="77"/>
                         </a:rPr>
-                        <a:t>trembling</a:t>
+                        <a:t>suspicious</a:t>
                       </a:r>
                     </a:p>
                     <a:p>
@@ -30668,7 +30690,7 @@
             <a:pPr algn="ctr"/>
             <a:r>
               <a:rPr lang="en-GB"/>
-              <a:t>trembling</a:t>
+              <a:t>suspicious</a:t>
             </a:r>
           </a:p>
         </p:txBody>
@@ -31265,7 +31287,14 @@
           <a:p>
             <a:r>
               <a:rPr lang="en-GB" sz="2200"/>
-              <a:t>Varjak had never left the tower before. For all of his short life, the ancient building had been his entire world — its cool stone corridors, its familiar smells, its safe, predictable rhythms. But now he stood at the great entrance, and the world beyond stretched out before him, vast and trembling in the early morning light. He felt overwhelmed. The sounds alone were enough to make his whiskers shake: the low rumble of distant engines, the clatter of pigeons overhead, the whisper of wind threading through the alleyways below. His paws pressed flat against the cold step as he cautiously peered outward, trying to make sense of what lay ahead. There was no map for this. No elder cat had told him what the city truly looked like from the ground, how enormous and uncertain it felt when you were standing inside it rather than gazing down from above. The horizon seemed impossibly far away, a smudge of grey and amber where the rooftops finally gave way to sky. Part of him wanted to turn back, to find his mother and curl up close. But somewhere deeper, in a place he had not known existed, something pulled him forward. He took one cautious breath. Then another. Then, trembling from his ears to the tip of his tail, Varjak Paw stepped out into the world.</a:t>
+              <a:t>Holly watched him from the top of the wall, her green eyes unblinking. She was smaller than Varjak had expected — lean and quick, with a nick in one ear and a look that said she had seen worse things than him. He tried to appear calm.
+"You're not from round here," she said. It was not a question.
+"No." Varjak straightened up, trying to look more confident than he felt. "My name is Varjak Paw. I came from —"
+"I know where you came from." Her tail flicked once. "That tower." She said it like it explained everything she needed to know, and not in a good way.
+Varjak bristled. He was not used to being dismissed before he had even spoken properly. "I'm looking for a dog," he said.
+Holly blinked. There was a long pause — the kind that made you want to fill it, which Varjak suspected was exactly why she left it there. When she finally spoke, there was something grudging in her voice, as though the words cost her.
+"That's the most ridiculous thing I've ever heard," she said. Then — and this surprised him completely — she dropped lightly down from the wall and landed at his side. "I'm Holly. If you're going after dogs, you need help whether you like it or not."
+Varjak stared. He felt something stir: not quite trust, but the first small seed of curiosity about what might come next.</a:t>
             </a:r>
             <a:endParaRPr lang="en-GB" sz="2200" noProof="0"/>
           </a:p>
@@ -37686,7 +37715,7 @@
             </a:pPr>
             <a:r>
               <a:rPr lang="en-GB" sz="2200"/>
-              <a:t>What sounds does Varjak hear when he looks outside?</a:t>
+              <a:t>How does Holly show she already knows where Varjak is from?</a:t>
             </a:r>
           </a:p>
           <a:p>
@@ -37697,7 +37726,7 @@
             </a:pPr>
             <a:r>
               <a:rPr lang="en-GB" sz="2200"/>
-              <a:t>He hears the low rumble of distant engines, the clatter of pigeons overhead and the whisper of wind threading through the alleyways below.</a:t>
+              <a:t>She says 'I know where you came from. That tower.' — she recognises him and mentions his home without him having to explain anything.</a:t>
             </a:r>
           </a:p>
           <a:p>
@@ -37716,7 +37745,7 @@
             </a:pPr>
             <a:r>
               <a:rPr lang="en-GB" sz="2200"/>
-              <a:t>What does the word 'trembling' mean? Use the context of the text to help you.</a:t>
+              <a:t>What does the word 'grudging' mean? Use the context of the text to help you.</a:t>
             </a:r>
           </a:p>
           <a:p>
@@ -37727,7 +37756,7 @@
             </a:pPr>
             <a:r>
               <a:rPr lang="en-GB" sz="2200"/>
-              <a:t>Trembling means shaking slightly. The text tells us Varjak is frightened by the outside world and at the end he is shaking 'from his ears to the tip of his tail', which shows the word describes frightened shaking.</a:t>
+              <a:t>Grudging means giving something unwillingly, without wanting to admit it. The text says the words 'cost her' — as though saying them out loud is difficult for Holly, which tells us she is admitting something she would rather not.</a:t>
             </a:r>
           </a:p>
           <a:p>
@@ -37880,7 +37909,14 @@
           <a:p>
             <a:r>
               <a:rPr lang="en-GB" sz="2200"/>
-              <a:t>Varjak had never left the tower before. For all of his short life, the ancient building had been his entire world — its cool stone corridors, its familiar smells, its safe, predictable rhythms. But now he stood at the great entrance, and the world beyond stretched out before him, vast and trembling in the early morning light. He felt overwhelmed. The sounds alone were enough to make his whiskers shake: the low rumble of distant engines, the clatter of pigeons overhead, the whisper of wind threading through the alleyways below. His paws pressed flat against the cold step as he cautiously peered outward, trying to make sense of what lay ahead. There was no map for this. No elder cat had told him what the city truly looked like from the ground, how enormous and uncertain it felt when you were standing inside it rather than gazing down from above. The horizon seemed impossibly far away, a smudge of grey and amber where the rooftops finally gave way to sky. Part of him wanted to turn back, to find his mother and curl up close. But somewhere deeper, in a place he had not known existed, something pulled him forward. He took one cautious breath. Then another. Then, trembling from his ears to the tip of his tail, Varjak Paw stepped out into the world.</a:t>
+              <a:t>Holly watched him from the top of the wall, her green eyes unblinking. She was smaller than Varjak had expected — lean and quick, with a nick in one ear and a look that said she had seen worse things than him. He tried to appear calm.
+"You're not from round here," she said. It was not a question.
+"No." Varjak straightened up, trying to look more confident than he felt. "My name is Varjak Paw. I came from —"
+"I know where you came from." Her tail flicked once. "That tower." She said it like it explained everything she needed to know, and not in a good way.
+Varjak bristled. He was not used to being dismissed before he had even spoken properly. "I'm looking for a dog," he said.
+Holly blinked. There was a long pause — the kind that made you want to fill it, which Varjak suspected was exactly why she left it there. When she finally spoke, there was something grudging in her voice, as though the words cost her.
+"That's the most ridiculous thing I've ever heard," she said. Then — and this surprised him completely — she dropped lightly down from the wall and landed at his side. "I'm Holly. If you're going after dogs, you need help whether you like it or not."
+Varjak stared. He felt something stir: not quite trust, but the first small seed of curiosity about what might come next.</a:t>
             </a:r>
           </a:p>
         </p:txBody>
@@ -38655,7 +38691,7 @@
             <a:pPr algn="ctr"/>
             <a:r>
               <a:rPr lang="en-GB" sz="8800" dirty="0"/>
-              <a:t>Thursday</a:t>
+              <a:t>Wednesday</a:t>
             </a:r>
           </a:p>
         </p:txBody>

</xml_diff>

<commit_message>
T6W2 Being a Reader — Varjak Paw (Tue/Wed/Thu)
</commit_message>
<xml_diff>
--- a/Reading/BeingAReader_Template.pptx
+++ b/Reading/BeingAReader_Template.pptx
@@ -6858,7 +6858,7 @@
                           <a:effectLst/>
                           <a:latin typeface="Calibri" panose="020F0502020204030204" pitchFamily="34" charset="0"/>
                         </a:rPr>
-                        <a:t>concentration</a:t>
+                        <a:t>overwhelming</a:t>
                       </a:r>
                     </a:p>
                   </a:txBody>
@@ -6917,7 +6917,7 @@
                           <a:effectLst/>
                           <a:latin typeface="Calibri" panose="020F0502020204030204" pitchFamily="34" charset="0"/>
                         </a:rPr>
-                        <a:t>giving all your attention and effort to one thing</a:t>
+                        <a:t>so strong or large that it is very hard to deal with</a:t>
                       </a:r>
                     </a:p>
                   </a:txBody>
@@ -6983,7 +6983,7 @@
                           <a:effectLst/>
                           <a:latin typeface="Calibri" panose="020F0502020204030204" pitchFamily="34" charset="0"/>
                         </a:rPr>
-                        <a:t>fierce</a:t>
+                        <a:t>looming</a:t>
                       </a:r>
                     </a:p>
                   </a:txBody>
@@ -7042,7 +7042,7 @@
                           <a:effectLst/>
                           <a:latin typeface="Calibri" panose="020F0502020204030204" pitchFamily="34" charset="0"/>
                         </a:rPr>
-                        <a:t>very strong and intense; powerful</a:t>
+                        <a:t>appearing large and threatening, especially in a shadowy or unclear way</a:t>
                       </a:r>
                     </a:p>
                   </a:txBody>
@@ -7108,7 +7108,7 @@
                           <a:effectLst/>
                           <a:latin typeface="Calibri" panose="020F0502020204030204" pitchFamily="34" charset="0"/>
                         </a:rPr>
-                        <a:t>precise</a:t>
+                        <a:t>hesitating</a:t>
                       </a:r>
                     </a:p>
                   </a:txBody>
@@ -7167,7 +7167,7 @@
                           <a:effectLst/>
                           <a:latin typeface="Calibri" panose="020F0502020204030204" pitchFamily="34" charset="0"/>
                         </a:rPr>
-                        <a:t>exact and accurate; done very carefully</a:t>
+                        <a:t>pausing before doing something because you are unsure</a:t>
                       </a:r>
                     </a:p>
                   </a:txBody>
@@ -7233,7 +7233,7 @@
                           <a:effectLst/>
                           <a:latin typeface="Calibri" panose="020F0502020204030204" pitchFamily="34" charset="0"/>
                         </a:rPr>
-                        <a:t>surge</a:t>
+                        <a:t>unfamiliar</a:t>
                       </a:r>
                     </a:p>
                   </a:txBody>
@@ -7292,7 +7292,7 @@
                           <a:effectLst/>
                           <a:latin typeface="Calibri" panose="020F0502020204030204" pitchFamily="34" charset="0"/>
                         </a:rPr>
-                        <a:t>a sudden, powerful rush of feeling or movement</a:t>
+                        <a:t>not known or recognised; something you have not experienced before</a:t>
                       </a:r>
                     </a:p>
                   </a:txBody>
@@ -7358,7 +7358,7 @@
                           <a:effectLst/>
                           <a:latin typeface="Calibri" panose="020F0502020204030204" pitchFamily="34" charset="0"/>
                         </a:rPr>
-                        <a:t>composed</a:t>
+                        <a:t>chaos</a:t>
                       </a:r>
                     </a:p>
                   </a:txBody>
@@ -7417,7 +7417,7 @@
                           <a:effectLst/>
                           <a:latin typeface="Calibri" panose="020F0502020204030204" pitchFamily="34" charset="0"/>
                         </a:rPr>
-                        <a:t>calm and in control of your feelings</a:t>
+                        <a:t>a state of complete confusion and disorder</a:t>
                       </a:r>
                     </a:p>
                   </a:txBody>
@@ -8497,7 +8497,7 @@
                           </a:solidFill>
                           <a:latin typeface="XCCW Joined 4a" panose="03050602040000000000" pitchFamily="66" charset="77"/>
                         </a:rPr>
-                        <a:t>fierce</a:t>
+                        <a:t>unfamiliar</a:t>
                       </a:r>
                     </a:p>
                     <a:p>
@@ -8847,7 +8847,7 @@
             <a:pPr algn="ctr"/>
             <a:r>
               <a:rPr lang="en-GB"/>
-              <a:t>fierce</a:t>
+              <a:t>unfamiliar</a:t>
             </a:r>
           </a:p>
         </p:txBody>
@@ -9511,13 +9511,7 @@
           <a:p>
             <a:r>
               <a:rPr lang="en-US" sz="2200" dirty="0"/>
-              <a:t>The first time Varjak used the Way in the real world, three cats had cornered him against a rusting fence. His heart was hammering. Every part of him wanted to run, but there was nowhere to go.
-So instead, he closed his eyes. He thought of the river in Jalal's teaching — water that did not fight the rocks but moved around them. He let his breathing slow. He felt the ground beneath his paws, solid and real, and he let himself become part of it.
-When he opened his eyes, something had shifted. The fear was still there, but it had moved somewhere quieter. His body felt steady. Composed.
-He moved — not away, but sideways, then through a gap he had not seen before, his body low and precise, each step placed with fierce concentration. The three cats watched, confused. They had expected panic. What they got was something altogether different.
-Varjak did not stop until he was two streets away, his heart still loud in his ears but his paws moving steadily beneath him. He sat down on a doorstep. He breathed.
-"That worked," he said aloud, to nobody.
-And then, slowly, he smiled.</a:t>
+              <a:t>Nothing had prepared Varjak for the city. As he picked his way along the edge of the pavement, everything around him seemed to shift and shout at once — the overwhelming noise of engines, voices, horns, and the constant rush of feet slamming against the ground. Buildings loomed over him on all sides, enormous and grey, their windows like blank and unseeing eyes staring down at him without interest. The smells were unlike anything he had ever known: petrol and fried food and damp concrete and something metallic that caught at the back of his throat and made him want to cough. He kept hesitating at the edge of roads, watching the cars surge past in a terrifying stream of metal and light, unsure how any creature could cross without being destroyed. Everything was unfamiliar — the sounds, the smells, even the quality of the light felt different here, thinner somehow, dirtier. Back on the mountain, he had always known exactly where he was; the land had felt like a part of him. Here, he was a stranger to every surface and every shadow. The chaos pressed in around him from all sides, and more than once he had to remind himself why he had come — to find help for his family, to do what no Mesopotamian Blue had ever done before. He took a shaky breath, pressed himself flat against a wall, and made himself keep going.</a:t>
             </a:r>
           </a:p>
         </p:txBody>
@@ -16044,13 +16038,13 @@
           <a:p>
             <a:r>
               <a:rPr lang="en-US" sz="1900"/>
-              <a:t>Give two details from the text that show the three cats are surprised by Varjak.</a:t>
+              <a:t>Name two things Varjak can hear in the city.</a:t>
             </a:r>
           </a:p>
           <a:p>
             <a:r>
               <a:rPr lang="en-US" sz="1900"/>
-              <a:t>The text says the cats 'watched, confused'. It also says 'they had expected panic' — both show the cats did not expect Varjak to respond the way he did.</a:t>
+              <a:t>He can hear engines, voices, horns and the rush of feet — any two are correct.</a:t>
             </a:r>
           </a:p>
           <a:p>
@@ -16059,13 +16053,13 @@
           <a:p>
             <a:r>
               <a:rPr lang="en-US" sz="1900"/>
-              <a:t>What does the word 'composed' mean? How does the context help you work it out?</a:t>
+              <a:t>How do the buildings make Varjak feel? Use evidence from the text.</a:t>
             </a:r>
           </a:p>
           <a:p>
             <a:r>
               <a:rPr lang="en-US" sz="1900"/>
-              <a:t>Composed means calm and in control. The context helps because just before, Varjak's heart was hammering and he wanted to run — so composed shows the opposite of that panic, a new stillness he has found through using the Way.</a:t>
+              <a:t>They have ‘blank and unseeing eyes’ — they make him feel watched but also ignored, as though the city does not care about him.</a:t>
             </a:r>
           </a:p>
         </p:txBody>
@@ -16105,13 +16099,7 @@
           <a:p>
             <a:r>
               <a:rPr lang="en-US" sz="2200"/>
-              <a:t>The first time Varjak used the Way in the real world, three cats had cornered him against a rusting fence. His heart was hammering. Every part of him wanted to run, but there was nowhere to go.
-So instead, he closed his eyes. He thought of the river in Jalal's teaching — water that did not fight the rocks but moved around them. He let his breathing slow. He felt the ground beneath his paws, solid and real, and he let himself become part of it.
-When he opened his eyes, something had shifted. The fear was still there, but it had moved somewhere quieter. His body felt steady. Composed.
-He moved — not away, but sideways, then through a gap he had not seen before, his body low and precise, each step placed with fierce concentration. The three cats watched, confused. They had expected panic. What they got was something altogether different.
-Varjak did not stop until he was two streets away, his heart still loud in his ears but his paws moving steadily beneath him. He sat down on a doorstep. He breathed.
-"That worked," he said aloud, to nobody.
-And then, slowly, he smiled.</a:t>
+              <a:t>Nothing had prepared Varjak for the city. As he picked his way along the edge of the pavement, everything around him seemed to shift and shout at once — the overwhelming noise of engines, voices, horns, and the constant rush of feet slamming against the ground. Buildings loomed over him on all sides, enormous and grey, their windows like blank and unseeing eyes staring down at him without interest. The smells were unlike anything he had ever known: petrol and fried food and damp concrete and something metallic that caught at the back of his throat and made him want to cough. He kept hesitating at the edge of roads, watching the cars surge past in a terrifying stream of metal and light, unsure how any creature could cross without being destroyed. Everything was unfamiliar — the sounds, the smells, even the quality of the light felt different here, thinner somehow, dirtier. Back on the mountain, he had always known exactly where he was; the land had felt like a part of him. Here, he was a stranger to every surface and every shadow. The chaos pressed in around him from all sides, and more than once he had to remind himself why he had come — to find help for his family, to do what no Mesopotamian Blue had ever done before. He took a shaky breath, pressed himself flat against a wall, and made himself keep going.</a:t>
             </a:r>
           </a:p>
         </p:txBody>
@@ -17797,7 +17785,7 @@
                           <a:effectLst/>
                           <a:latin typeface="Calibri" panose="020F0502020204030204" pitchFamily="34" charset="0"/>
                         </a:rPr>
-                        <a:t>conflicted</a:t>
+                        <a:t>instinct</a:t>
                       </a:r>
                     </a:p>
                   </a:txBody>
@@ -17856,7 +17844,7 @@
                           <a:effectLst/>
                           <a:latin typeface="Calibri" panose="020F0502020204030204" pitchFamily="34" charset="0"/>
                         </a:rPr>
-                        <a:t>having two opposing feelings or ideas at the same time; torn</a:t>
+                        <a:t>a natural feeling that makes you behave in a particular way without thinking</a:t>
                       </a:r>
                     </a:p>
                   </a:txBody>
@@ -17922,7 +17910,7 @@
                           <a:effectLst/>
                           <a:latin typeface="Calibri" panose="020F0502020204030204" pitchFamily="34" charset="0"/>
                         </a:rPr>
-                        <a:t>burden</a:t>
+                        <a:t>cautious</a:t>
                       </a:r>
                     </a:p>
                   </a:txBody>
@@ -17981,7 +17969,7 @@
                           <a:effectLst/>
                           <a:latin typeface="Calibri" panose="020F0502020204030204" pitchFamily="34" charset="0"/>
                         </a:rPr>
-                        <a:t>a heavy load — either physical or emotional — that you have to carry</a:t>
+                        <a:t>careful to avoid danger; not taking risks</a:t>
                       </a:r>
                     </a:p>
                   </a:txBody>
@@ -18047,7 +18035,7 @@
                           <a:effectLst/>
                           <a:latin typeface="Calibri" panose="020F0502020204030204" pitchFamily="34" charset="0"/>
                         </a:rPr>
-                        <a:t>worthwhile</a:t>
+                        <a:t>unlikely</a:t>
                       </a:r>
                     </a:p>
                   </a:txBody>
@@ -18106,7 +18094,7 @@
                           <a:effectLst/>
                           <a:latin typeface="Calibri" panose="020F0502020204030204" pitchFamily="34" charset="0"/>
                         </a:rPr>
-                        <a:t>important or useful enough to make the effort</a:t>
+                        <a:t>not expected to happen; surprising or improbable</a:t>
                       </a:r>
                     </a:p>
                   </a:txBody>
@@ -18172,7 +18160,7 @@
                           <a:effectLst/>
                           <a:latin typeface="Calibri" panose="020F0502020204030204" pitchFamily="34" charset="0"/>
                         </a:rPr>
-                        <a:t>weary</a:t>
+                        <a:t>vulnerable</a:t>
                       </a:r>
                     </a:p>
                   </a:txBody>
@@ -18231,7 +18219,7 @@
                           <a:effectLst/>
                           <a:latin typeface="Calibri" panose="020F0502020204030204" pitchFamily="34" charset="0"/>
                         </a:rPr>
-                        <a:t>very tired, especially after a long time doing something difficult</a:t>
+                        <a:t>in a position where you could easily be hurt or harmed</a:t>
                       </a:r>
                     </a:p>
                   </a:txBody>
@@ -18297,7 +18285,7 @@
                           <a:effectLst/>
                           <a:latin typeface="Calibri" panose="020F0502020204030204" pitchFamily="34" charset="0"/>
                         </a:rPr>
-                        <a:t>stubborn</a:t>
+                        <a:t>loyal</a:t>
                       </a:r>
                     </a:p>
                   </a:txBody>
@@ -18356,7 +18344,7 @@
                           <a:effectLst/>
                           <a:latin typeface="Calibri" panose="020F0502020204030204" pitchFamily="34" charset="0"/>
                         </a:rPr>
-                        <a:t>refusing to change your mind or give up, even when things are hard</a:t>
+                        <a:t>remaining faithful and supportive to someone even when things are difficult</a:t>
                       </a:r>
                     </a:p>
                   </a:txBody>
@@ -19436,7 +19424,7 @@
                           </a:solidFill>
                           <a:latin typeface="XCCW Joined 4a" panose="03050602040000000000" pitchFamily="66" charset="77"/>
                         </a:rPr>
-                        <a:t>conflicted</a:t>
+                        <a:t>cautious</a:t>
                       </a:r>
                     </a:p>
                     <a:p>
@@ -19786,7 +19774,7 @@
             <a:pPr algn="ctr"/>
             <a:r>
               <a:rPr lang="en-GB"/>
-              <a:t>conflicted</a:t>
+              <a:t>cautious</a:t>
             </a:r>
           </a:p>
         </p:txBody>
@@ -20707,12 +20695,7 @@
           <a:p>
             <a:r>
               <a:rPr lang="en-US" sz="2200" dirty="0"/>
-              <a:t>The rain had been falling for hours. Varjak sat under the lip of a drainpipe, watching the gutters fill, feeling the cold settle into his bones. He had not found what he was looking for. He had not even come close.
-He thought about home. It came to him in pieces — the smell of warm stone, the weight of his mother's paw on the back of his neck when he was small, the sound of his brothers breathing in the dark. He had carried all of it with him since the moment he left, a burden he had not known he was lifting.
-He could go back. He knew that. Nobody had told him he had to stay. The Way could get him there — he was sure of it now. He could be home by morning, warm and safe, with the family he had not stopped missing for a single day.
-But then he thought of what waited in the tower. The Gentleman. The dark cats. His mother and brothers trapped behind those walls. He thought of Elder Paw's last words to him, weary with age but stubborn as stone: there is only one who can save us now.
-Could he really turn back? Could he live with himself if he did?
-He sat with the question a long time. The rain kept falling. He did not move.</a:t>
+              <a:t>Cludge did not look like a friend. He was enormous — far bigger than any creature Varjak had encountered in the city — with a coat the colour of mud and paws like small boulders. When Varjak first spotted him, every instinct told him to run: his fur bristled, his claws flexed, and his heart hammered against his ribs in a rhythm that had only one word in it. Danger. But Cludge simply sat there in the rain, blinking his enormous, slow eyes, and something in his stillness made Varjak pause. He had never expected to feel anything other than fear around a dog. He remained cautious, keeping low to the ground and watching every tiny movement, yet he did not leave. There was something in the dog’s expression — a kind of sadness, a kind of loneliness — that Varjak recognised, because he had felt it himself ever since arriving in the city. Slowly, hesitantly, he crept a little closer. It was perhaps the most unlikely friendship either of them had ever imagined. Varjak was a kitten, small and vulnerable, far from everything he had ever known. Cludge was a stray, enormous and gentle, with no one in the world. But as the rain fell quietly around them and neither of them moved away, something passed between them that neither could have named — the first, fragile thread of something that might one day become loyal and true.</a:t>
             </a:r>
           </a:p>
         </p:txBody>
@@ -27239,13 +27222,13 @@
           <a:p>
             <a:r>
               <a:rPr lang="en-US" sz="1900"/>
-              <a:t>What three things does Varjak remember about home?</a:t>
+              <a:t>How does Varjak feel when he first sees Cludge? Use evidence from the text.</a:t>
             </a:r>
           </a:p>
           <a:p>
             <a:r>
               <a:rPr lang="en-US" sz="1900"/>
-              <a:t>He thinks about the smell of warm stone, the weight of his mother's paw on the back of his neck when he was small, and the sound of his brothers breathing in the dark.</a:t>
+              <a:t>He feels afraid — his ‘fur bristled, his claws flexed, and his heart hammered’, showing his body reacted as though he was in danger.</a:t>
             </a:r>
           </a:p>
           <a:p>
@@ -27254,13 +27237,13 @@
           <a:p>
             <a:r>
               <a:rPr lang="en-US" sz="1900"/>
-              <a:t>What does the word 'burden' mean? How does the writer use it here?</a:t>
+              <a:t>Find a word or phrase from the text that shows Varjak did not fully trust Cludge at first.</a:t>
             </a:r>
           </a:p>
           <a:p>
             <a:r>
               <a:rPr lang="en-US" sz="1900"/>
-              <a:t>A burden is a heavy load you carry. The writer uses it to describe Varjak's memories of home — precious but exhausting to carry. He describes it as 'a burden he had not known he was lifting', showing the weight of missing home had been there all along without him realising it.</a:t>
+              <a:t>‘He remained cautious, keeping low to the ground’ — this shows he was careful and watchful rather than relaxed.</a:t>
             </a:r>
           </a:p>
         </p:txBody>
@@ -27300,12 +27283,7 @@
           <a:p>
             <a:r>
               <a:rPr lang="en-US" sz="2200"/>
-              <a:t>The rain had been falling for hours. Varjak sat under the lip of a drainpipe, watching the gutters fill, feeling the cold settle into his bones. He had not found what he was looking for. He had not even come close.
-He thought about home. It came to him in pieces — the smell of warm stone, the weight of his mother's paw on the back of his neck when he was small, the sound of his brothers breathing in the dark. He had carried all of it with him since the moment he left, a burden he had not known he was lifting.
-He could go back. He knew that. Nobody had told him he had to stay. The Way could get him there — he was sure of it now. He could be home by morning, warm and safe, with the family he had not stopped missing for a single day.
-But then he thought of what waited in the tower. The Gentleman. The dark cats. His mother and brothers trapped behind those walls. He thought of Elder Paw's last words to him, weary with age but stubborn as stone: there is only one who can save us now.
-Could he really turn back? Could he live with himself if he did?
-He sat with the question a long time. The rain kept falling. He did not move.</a:t>
+              <a:t>Cludge did not look like a friend. He was enormous — far bigger than any creature Varjak had encountered in the city — with a coat the colour of mud and paws like small boulders. When Varjak first spotted him, every instinct told him to run: his fur bristled, his claws flexed, and his heart hammered against his ribs in a rhythm that had only one word in it. Danger. But Cludge simply sat there in the rain, blinking his enormous, slow eyes, and something in his stillness made Varjak pause. He had never expected to feel anything other than fear around a dog. He remained cautious, keeping low to the ground and watching every tiny movement, yet he did not leave. There was something in the dog’s expression — a kind of sadness, a kind of loneliness — that Varjak recognised, because he had felt it himself ever since arriving in the city. Slowly, hesitantly, he crept a little closer. It was perhaps the most unlikely friendship either of them had ever imagined. Varjak was a kitten, small and vulnerable, far from everything he had ever known. Cludge was a stray, enormous and gentle, with no one in the world. But as the rain fell quietly around them and neither of them moved away, something passed between them that neither could have named — the first, fragile thread of something that might one day become loyal and true.</a:t>
             </a:r>
           </a:p>
         </p:txBody>
@@ -28694,7 +28672,7 @@
                           <a:effectLst/>
                           <a:latin typeface="Calibri" panose="020F0502020204030204" pitchFamily="34" charset="0"/>
                         </a:rPr>
-                        <a:t>suspicious</a:t>
+                        <a:t>ancient</a:t>
                       </a:r>
                     </a:p>
                   </a:txBody>
@@ -28753,7 +28731,7 @@
                           <a:effectLst/>
                           <a:latin typeface="Calibri" panose="020F0502020204030204" pitchFamily="34" charset="0"/>
                         </a:rPr>
-                        <a:t>not trusting someone; thinking they might cause trouble</a:t>
+                        <a:t>very old; having existed for a very long time</a:t>
                       </a:r>
                     </a:p>
                   </a:txBody>
@@ -28819,7 +28797,7 @@
                           <a:effectLst/>
                           <a:latin typeface="Calibri" panose="020F0502020204030204" pitchFamily="34" charset="0"/>
                         </a:rPr>
-                        <a:t>wary</a:t>
+                        <a:t>trembling</a:t>
                       </a:r>
                     </a:p>
                   </a:txBody>
@@ -28878,7 +28856,7 @@
                           <a:effectLst/>
                           <a:latin typeface="Calibri" panose="020F0502020204030204" pitchFamily="34" charset="0"/>
                         </a:rPr>
-                        <a:t>careful and watchful, not fully trusting a situation or person</a:t>
+                        <a:t>shaking slightly because of fear, cold or strong feelings</a:t>
                       </a:r>
                     </a:p>
                   </a:txBody>
@@ -28944,7 +28922,7 @@
                           <a:effectLst/>
                           <a:latin typeface="Calibri" panose="020F0502020204030204" pitchFamily="34" charset="0"/>
                         </a:rPr>
-                        <a:t>defiant</a:t>
+                        <a:t>persistent</a:t>
                       </a:r>
                     </a:p>
                   </a:txBody>
@@ -29003,7 +28981,7 @@
                           <a:effectLst/>
                           <a:latin typeface="Calibri" panose="020F0502020204030204" pitchFamily="34" charset="0"/>
                         </a:rPr>
-                        <a:t>refusing to obey or be controlled; standing up against something</a:t>
+                        <a:t>continuing to try even when something is difficult</a:t>
                       </a:r>
                     </a:p>
                   </a:txBody>
@@ -29069,7 +29047,7 @@
                           <a:effectLst/>
                           <a:latin typeface="Calibri" panose="020F0502020204030204" pitchFamily="34" charset="0"/>
                         </a:rPr>
-                        <a:t>grudging</a:t>
+                        <a:t>glimpse</a:t>
                       </a:r>
                     </a:p>
                   </a:txBody>
@@ -29128,7 +29106,7 @@
                           <a:effectLst/>
                           <a:latin typeface="Calibri" panose="020F0502020204030204" pitchFamily="34" charset="0"/>
                         </a:rPr>
-                        <a:t>given unwillingly, without wanting to admit it</a:t>
+                        <a:t>a very quick, brief look at something</a:t>
                       </a:r>
                     </a:p>
                   </a:txBody>
@@ -29194,7 +29172,7 @@
                           <a:effectLst/>
                           <a:latin typeface="Calibri" panose="020F0502020204030204" pitchFamily="34" charset="0"/>
                         </a:rPr>
-                        <a:t>curiosity</a:t>
+                        <a:t>stirring</a:t>
                       </a:r>
                     </a:p>
                   </a:txBody>
@@ -29253,7 +29231,7 @@
                           <a:effectLst/>
                           <a:latin typeface="Calibri" panose="020F0502020204030204" pitchFamily="34" charset="0"/>
                         </a:rPr>
-                        <a:t>a strong desire to know or find out more about something</a:t>
+                        <a:t>beginning to move or become active; starting to feel something</a:t>
                       </a:r>
                     </a:p>
                   </a:txBody>
@@ -30340,7 +30318,7 @@
                           </a:solidFill>
                           <a:latin typeface="Twinkl Cursive Looped Light" panose="02000000000000000000" pitchFamily="2" charset="77"/>
                         </a:rPr>
-                        <a:t>suspicious</a:t>
+                        <a:t>persistent</a:t>
                       </a:r>
                     </a:p>
                     <a:p>
@@ -30690,7 +30668,7 @@
             <a:pPr algn="ctr"/>
             <a:r>
               <a:rPr lang="en-GB"/>
-              <a:t>suspicious</a:t>
+              <a:t>persistent</a:t>
             </a:r>
           </a:p>
         </p:txBody>
@@ -31287,14 +31265,7 @@
           <a:p>
             <a:r>
               <a:rPr lang="en-GB" sz="2200"/>
-              <a:t>Holly watched him from the top of the wall, her green eyes unblinking. She was smaller than Varjak had expected — lean and quick, with a nick in one ear and a look that said she had seen worse things than him. He tried to appear calm.
-"You're not from round here," she said. It was not a question.
-"No." Varjak straightened up, trying to look more confident than he felt. "My name is Varjak Paw. I came from —"
-"I know where you came from." Her tail flicked once. "That tower." She said it like it explained everything she needed to know, and not in a good way.
-Varjak bristled. He was not used to being dismissed before he had even spoken properly. "I'm looking for a dog," he said.
-Holly blinked. There was a long pause — the kind that made you want to fill it, which Varjak suspected was exactly why she left it there. When she finally spoke, there was something grudging in her voice, as though the words cost her.
-"That's the most ridiculous thing I've ever heard," she said. Then — and this surprised him completely — she dropped lightly down from the wall and landed at his side. "I'm Holly. If you're going after dogs, you need help whether you like it or not."
-Varjak stared. He felt something stir: not quite trust, but the first small seed of curiosity about what might come next.</a:t>
+              <a:t>In the silence of the mountain, Varjak crouched low on the cold stone and tried once again to still his mind. The Way of Jalal was ancient — older than anything his family could remember — and Varjak had always believed it was just a story that Elder Paw whispered on quiet evenings. But now, as he closed his eyes and reached inside himself for something he could not yet name, he understood that it was far more than a tale. His legs were trembling with the effort of holding the same position for so long, and sweat dampened the fine fur beneath his chin. He tried to shut out the sounds of the world: the wind moving through the grass, his grandmother’s distant voice calling across the hillside. A persistent voice in his head told him he was doing it wrong, that he was too young, too small, too ordinary to learn what the great Jalal had taught. Yet somewhere deep in his chest, something was stirring — a tiny flicker of warmth that refused to go out no matter how many times doubt tried to smother it. When he opened his eyes, he caught a glimpse of a world that looked exactly as it always had, and yet somehow felt entirely different. Whatever the Way was, it was waking up inside him, and Varjak was just beginning to understand why that mattered.</a:t>
             </a:r>
             <a:endParaRPr lang="en-GB" sz="2200" noProof="0"/>
           </a:p>
@@ -37715,7 +37686,7 @@
             </a:pPr>
             <a:r>
               <a:rPr lang="en-GB" sz="2200"/>
-              <a:t>How does Holly show she already knows where Varjak is from?</a:t>
+              <a:t>What is Varjak trying to do in this extract?</a:t>
             </a:r>
           </a:p>
           <a:p>
@@ -37726,7 +37697,7 @@
             </a:pPr>
             <a:r>
               <a:rPr lang="en-GB" sz="2200"/>
-              <a:t>She says 'I know where you came from. That tower.' — she recognises him and mentions his home without him having to explain anything.</a:t>
+              <a:t>He is trying to learn the Way of Jalal, an ancient skill, by staying still and focusing his mind.</a:t>
             </a:r>
           </a:p>
           <a:p>
@@ -37745,7 +37716,7 @@
             </a:pPr>
             <a:r>
               <a:rPr lang="en-GB" sz="2200"/>
-              <a:t>What does the word 'grudging' mean? Use the context of the text to help you.</a:t>
+              <a:t>Find a word in the text that means ‘continuing to try even when something is difficult’.</a:t>
             </a:r>
           </a:p>
           <a:p>
@@ -37756,7 +37727,7 @@
             </a:pPr>
             <a:r>
               <a:rPr lang="en-GB" sz="2200"/>
-              <a:t>Grudging means giving something unwillingly, without wanting to admit it. The text says the words 'cost her' — as though saying them out loud is difficult for Holly, which tells us she is admitting something she would rather not.</a:t>
+              <a:t>persistent</a:t>
             </a:r>
           </a:p>
           <a:p>
@@ -37909,14 +37880,7 @@
           <a:p>
             <a:r>
               <a:rPr lang="en-GB" sz="2200"/>
-              <a:t>Holly watched him from the top of the wall, her green eyes unblinking. She was smaller than Varjak had expected — lean and quick, with a nick in one ear and a look that said she had seen worse things than him. He tried to appear calm.
-"You're not from round here," she said. It was not a question.
-"No." Varjak straightened up, trying to look more confident than he felt. "My name is Varjak Paw. I came from —"
-"I know where you came from." Her tail flicked once. "That tower." She said it like it explained everything she needed to know, and not in a good way.
-Varjak bristled. He was not used to being dismissed before he had even spoken properly. "I'm looking for a dog," he said.
-Holly blinked. There was a long pause — the kind that made you want to fill it, which Varjak suspected was exactly why she left it there. When she finally spoke, there was something grudging in her voice, as though the words cost her.
-"That's the most ridiculous thing I've ever heard," she said. Then — and this surprised him completely — she dropped lightly down from the wall and landed at his side. "I'm Holly. If you're going after dogs, you need help whether you like it or not."
-Varjak stared. He felt something stir: not quite trust, but the first small seed of curiosity about what might come next.</a:t>
+              <a:t>In the silence of the mountain, Varjak crouched low on the cold stone and tried once again to still his mind. The Way of Jalal was ancient — older than anything his family could remember — and Varjak had always believed it was just a story that Elder Paw whispered on quiet evenings. But now, as he closed his eyes and reached inside himself for something he could not yet name, he understood that it was far more than a tale. His legs were trembling with the effort of holding the same position for so long, and sweat dampened the fine fur beneath his chin. He tried to shut out the sounds of the world: the wind moving through the grass, his grandmother’s distant voice calling across the hillside. A persistent voice in his head told him he was doing it wrong, that he was too young, too small, too ordinary to learn what the great Jalal had taught. Yet somewhere deep in his chest, something was stirring — a tiny flicker of warmth that refused to go out no matter how many times doubt tried to smother it. When he opened his eyes, he caught a glimpse of a world that looked exactly as it always had, and yet somehow felt entirely different. Whatever the Way was, it was waking up inside him, and Varjak was just beginning to understand why that mattered.</a:t>
             </a:r>
           </a:p>
         </p:txBody>

</xml_diff>

<commit_message>
T6W3 Being a Reader — cat behaviour explanation text (Tue/Thu/Fri)
</commit_message>
<xml_diff>
--- a/Reading/BeingAReader_Template.pptx
+++ b/Reading/BeingAReader_Template.pptx
@@ -6858,7 +6858,7 @@
                           <a:effectLst/>
                           <a:latin typeface="Calibri" panose="020F0502020204030204" pitchFamily="34" charset="0"/>
                         </a:rPr>
-                        <a:t>overwhelming</a:t>
+                        <a:t>sequence</a:t>
                       </a:r>
                     </a:p>
                   </a:txBody>
@@ -6917,7 +6917,7 @@
                           <a:effectLst/>
                           <a:latin typeface="Calibri" panose="020F0502020204030204" pitchFamily="34" charset="0"/>
                         </a:rPr>
-                        <a:t>so strong or large that it is very hard to deal with</a:t>
+                        <a:t>a set of events or actions that happen in a particular order</a:t>
                       </a:r>
                     </a:p>
                   </a:txBody>
@@ -6983,7 +6983,7 @@
                           <a:effectLst/>
                           <a:latin typeface="Calibri" panose="020F0502020204030204" pitchFamily="34" charset="0"/>
                         </a:rPr>
-                        <a:t>looming</a:t>
+                        <a:t>process</a:t>
                       </a:r>
                     </a:p>
                   </a:txBody>
@@ -7042,7 +7042,7 @@
                           <a:effectLst/>
                           <a:latin typeface="Calibri" panose="020F0502020204030204" pitchFamily="34" charset="0"/>
                         </a:rPr>
-                        <a:t>appearing large and threatening, especially in a shadowy or unclear way</a:t>
+                        <a:t>a series of actions or steps taken to achieve a result</a:t>
                       </a:r>
                     </a:p>
                   </a:txBody>
@@ -7108,7 +7108,7 @@
                           <a:effectLst/>
                           <a:latin typeface="Calibri" panose="020F0502020204030204" pitchFamily="34" charset="0"/>
                         </a:rPr>
-                        <a:t>hesitating</a:t>
+                        <a:t>adapt</a:t>
                       </a:r>
                     </a:p>
                   </a:txBody>
@@ -7167,7 +7167,7 @@
                           <a:effectLst/>
                           <a:latin typeface="Calibri" panose="020F0502020204030204" pitchFamily="34" charset="0"/>
                         </a:rPr>
-                        <a:t>pausing before doing something because you are unsure</a:t>
+                        <a:t>to change in order to suit a different situation or environment</a:t>
                       </a:r>
                     </a:p>
                   </a:txBody>
@@ -7233,7 +7233,7 @@
                           <a:effectLst/>
                           <a:latin typeface="Calibri" panose="020F0502020204030204" pitchFamily="34" charset="0"/>
                         </a:rPr>
-                        <a:t>unfamiliar</a:t>
+                        <a:t>nocturnal</a:t>
                       </a:r>
                     </a:p>
                   </a:txBody>
@@ -7292,7 +7292,7 @@
                           <a:effectLst/>
                           <a:latin typeface="Calibri" panose="020F0502020204030204" pitchFamily="34" charset="0"/>
                         </a:rPr>
-                        <a:t>not known or recognised; something you have not experienced before</a:t>
+                        <a:t>active mainly at night rather than during the day</a:t>
                       </a:r>
                     </a:p>
                   </a:txBody>
@@ -7358,7 +7358,7 @@
                           <a:effectLst/>
                           <a:latin typeface="Calibri" panose="020F0502020204030204" pitchFamily="34" charset="0"/>
                         </a:rPr>
-                        <a:t>chaos</a:t>
+                        <a:t>predator</a:t>
                       </a:r>
                     </a:p>
                   </a:txBody>
@@ -7417,7 +7417,7 @@
                           <a:effectLst/>
                           <a:latin typeface="Calibri" panose="020F0502020204030204" pitchFamily="34" charset="0"/>
                         </a:rPr>
-                        <a:t>a state of complete confusion and disorder</a:t>
+                        <a:t>an animal that hunts and kills other animals for food</a:t>
                       </a:r>
                     </a:p>
                   </a:txBody>
@@ -8497,7 +8497,7 @@
                           </a:solidFill>
                           <a:latin typeface="XCCW Joined 4a" panose="03050602040000000000" pitchFamily="66" charset="77"/>
                         </a:rPr>
-                        <a:t>unfamiliar</a:t>
+                        <a:t>adapt</a:t>
                       </a:r>
                     </a:p>
                     <a:p>
@@ -8847,7 +8847,7 @@
             <a:pPr algn="ctr"/>
             <a:r>
               <a:rPr lang="en-GB"/>
-              <a:t>unfamiliar</a:t>
+              <a:t>adapt</a:t>
             </a:r>
           </a:p>
         </p:txBody>
@@ -9511,7 +9511,7 @@
           <a:p>
             <a:r>
               <a:rPr lang="en-US" sz="2200" dirty="0"/>
-              <a:t>Nothing had prepared Varjak for the city. As he picked his way along the edge of the pavement, everything around him seemed to shift and shout at once — the overwhelming noise of engines, voices, horns, and the constant rush of feet slamming against the ground. Buildings loomed over him on all sides, enormous and grey, their windows like blank and unseeing eyes staring down at him without interest. The smells were unlike anything he had ever known: petrol and fried food and damp concrete and something metallic that caught at the back of his throat and made him want to cough. He kept hesitating at the edge of roads, watching the cars surge past in a terrifying stream of metal and light, unsure how any creature could cross without being destroyed. Everything was unfamiliar — the sounds, the smells, even the quality of the light felt different here, thinner somehow, dirtier. Back on the mountain, he had always known exactly where he was; the land had felt like a part of him. Here, he was a stranger to every surface and every shadow. The chaos pressed in around him from all sides, and more than once he had to remind himself why he had come — to find help for his family, to do what no Mesopotamian Blue had ever done before. He took a shaky breath, pressed himself flat against a wall, and made himself keep going.</a:t>
+              <a:t>Unlike many animals, cats do not need to be taught most of their behaviours. A kitten is born with many responses already in place. For example, the instinct to crouch and stalk before pouncing is present almost from birth, even in kittens that have never seen prey. However, learning does play an important role in a cat’s development. A mother cat will teach her kittens how to hunt by first bringing them injured prey, then later taking them to observe while she hunts. This sequence of learning — moving from watching to copying to independent action — is a pattern found across many animal species. Cats also adapt their behaviour based on experience. A cat that has learned that a particular sound means food will respond to that sound reliably, even years later. This process of learning through repeated experience is called conditioning. Nocturnal by preference, cats are most active at dawn and dusk, when their prey is also on the move. During the day, cats conserve energy by sleeping, sometimes for up to sixteen hours. When night falls, the same cat becomes an efficient, focused predator, moving through its territory with purpose and precision. Understanding how cats learn and adapt helps us to appreciate why they behave as they do, and why domestic cats retain so many of the instincts of their wild ancestors.</a:t>
             </a:r>
           </a:p>
         </p:txBody>
@@ -16038,13 +16038,13 @@
           <a:p>
             <a:r>
               <a:rPr lang="en-US" sz="1900"/>
-              <a:t>Name two things Varjak can hear in the city.</a:t>
+              <a:t>What do kittens learn from their mother, according to the text?</a:t>
             </a:r>
           </a:p>
           <a:p>
             <a:r>
               <a:rPr lang="en-US" sz="1900"/>
-              <a:t>He can hear engines, voices, horns and the rush of feet — any two are correct.</a:t>
+              <a:t>Kittens learn to hunt. Their mother first brings them injured prey, then lets them watch her, and finally encourages them to try alone.</a:t>
             </a:r>
           </a:p>
           <a:p>
@@ -16053,13 +16053,13 @@
           <a:p>
             <a:r>
               <a:rPr lang="en-US" sz="1900"/>
-              <a:t>How do the buildings make Varjak feel? Use evidence from the text.</a:t>
+              <a:t>Find two facts from the text about how cats spend their time during the day.</a:t>
             </a:r>
           </a:p>
           <a:p>
             <a:r>
               <a:rPr lang="en-US" sz="1900"/>
-              <a:t>They have ‘blank and unseeing eyes’ — they make him feel watched but also ignored, as though the city does not care about him.</a:t>
+              <a:t>Cats sleep to conserve energy — sometimes up to sixteen hours. They are most active at dawn and dusk, not during the day.</a:t>
             </a:r>
           </a:p>
         </p:txBody>
@@ -16099,7 +16099,7 @@
           <a:p>
             <a:r>
               <a:rPr lang="en-US" sz="2200"/>
-              <a:t>Nothing had prepared Varjak for the city. As he picked his way along the edge of the pavement, everything around him seemed to shift and shout at once — the overwhelming noise of engines, voices, horns, and the constant rush of feet slamming against the ground. Buildings loomed over him on all sides, enormous and grey, their windows like blank and unseeing eyes staring down at him without interest. The smells were unlike anything he had ever known: petrol and fried food and damp concrete and something metallic that caught at the back of his throat and made him want to cough. He kept hesitating at the edge of roads, watching the cars surge past in a terrifying stream of metal and light, unsure how any creature could cross without being destroyed. Everything was unfamiliar — the sounds, the smells, even the quality of the light felt different here, thinner somehow, dirtier. Back on the mountain, he had always known exactly where he was; the land had felt like a part of him. Here, he was a stranger to every surface and every shadow. The chaos pressed in around him from all sides, and more than once he had to remind himself why he had come — to find help for his family, to do what no Mesopotamian Blue had ever done before. He took a shaky breath, pressed himself flat against a wall, and made himself keep going.</a:t>
+              <a:t>Unlike many animals, cats do not need to be taught most of their behaviours. A kitten is born with many responses already in place. For example, the instinct to crouch and stalk before pouncing is present almost from birth, even in kittens that have never seen prey. However, learning does play an important role in a cat’s development. A mother cat will teach her kittens how to hunt by first bringing them injured prey, then later taking them to observe while she hunts. This sequence of learning — moving from watching to copying to independent action — is a pattern found across many animal species. Cats also adapt their behaviour based on experience. A cat that has learned that a particular sound means food will respond to that sound reliably, even years later. This process of learning through repeated experience is called conditioning. Nocturnal by preference, cats are most active at dawn and dusk, when their prey is also on the move. During the day, cats conserve energy by sleeping, sometimes for up to sixteen hours. When night falls, the same cat becomes an efficient, focused predator, moving through its territory with purpose and precision. Understanding how cats learn and adapt helps us to appreciate why they behave as they do, and why domestic cats retain so many of the instincts of their wild ancestors.</a:t>
             </a:r>
           </a:p>
         </p:txBody>
@@ -16745,7 +16745,7 @@
             <a:pPr algn="ctr"/>
             <a:r>
               <a:rPr lang="en-GB" sz="8800" dirty="0"/>
-              <a:t>Thursday</a:t>
+              <a:t>Friday</a:t>
             </a:r>
           </a:p>
         </p:txBody>
@@ -17785,7 +17785,7 @@
                           <a:effectLst/>
                           <a:latin typeface="Calibri" panose="020F0502020204030204" pitchFamily="34" charset="0"/>
                         </a:rPr>
-                        <a:t>instinct</a:t>
+                        <a:t>formal</a:t>
                       </a:r>
                     </a:p>
                   </a:txBody>
@@ -17844,7 +17844,7 @@
                           <a:effectLst/>
                           <a:latin typeface="Calibri" panose="020F0502020204030204" pitchFamily="34" charset="0"/>
                         </a:rPr>
-                        <a:t>a natural feeling that makes you behave in a particular way without thinking</a:t>
+                        <a:t>following a fixed, serious style; not casual or conversational</a:t>
                       </a:r>
                     </a:p>
                   </a:txBody>
@@ -17910,7 +17910,7 @@
                           <a:effectLst/>
                           <a:latin typeface="Calibri" panose="020F0502020204030204" pitchFamily="34" charset="0"/>
                         </a:rPr>
-                        <a:t>cautious</a:t>
+                        <a:t>technical</a:t>
                       </a:r>
                     </a:p>
                   </a:txBody>
@@ -17969,7 +17969,7 @@
                           <a:effectLst/>
                           <a:latin typeface="Calibri" panose="020F0502020204030204" pitchFamily="34" charset="0"/>
                         </a:rPr>
-                        <a:t>careful to avoid danger; not taking risks</a:t>
+                        <a:t>relating to the specific knowledge or language of a subject</a:t>
                       </a:r>
                     </a:p>
                   </a:txBody>
@@ -18035,7 +18035,7 @@
                           <a:effectLst/>
                           <a:latin typeface="Calibri" panose="020F0502020204030204" pitchFamily="34" charset="0"/>
                         </a:rPr>
-                        <a:t>unlikely</a:t>
+                        <a:t>causal</a:t>
                       </a:r>
                     </a:p>
                   </a:txBody>
@@ -18094,7 +18094,7 @@
                           <a:effectLst/>
                           <a:latin typeface="Calibri" panose="020F0502020204030204" pitchFamily="34" charset="0"/>
                         </a:rPr>
-                        <a:t>not expected to happen; surprising or improbable</a:t>
+                        <a:t>relating to or describing a cause; explaining why something happens</a:t>
                       </a:r>
                     </a:p>
                   </a:txBody>
@@ -18160,7 +18160,7 @@
                           <a:effectLst/>
                           <a:latin typeface="Calibri" panose="020F0502020204030204" pitchFamily="34" charset="0"/>
                         </a:rPr>
-                        <a:t>vulnerable</a:t>
+                        <a:t>convey</a:t>
                       </a:r>
                     </a:p>
                   </a:txBody>
@@ -18219,7 +18219,7 @@
                           <a:effectLst/>
                           <a:latin typeface="Calibri" panose="020F0502020204030204" pitchFamily="34" charset="0"/>
                         </a:rPr>
-                        <a:t>in a position where you could easily be hurt or harmed</a:t>
+                        <a:t>to communicate an idea or meaning clearly to someone else</a:t>
                       </a:r>
                     </a:p>
                   </a:txBody>
@@ -18285,7 +18285,7 @@
                           <a:effectLst/>
                           <a:latin typeface="Calibri" panose="020F0502020204030204" pitchFamily="34" charset="0"/>
                         </a:rPr>
-                        <a:t>loyal</a:t>
+                        <a:t>purpose</a:t>
                       </a:r>
                     </a:p>
                   </a:txBody>
@@ -18344,7 +18344,7 @@
                           <a:effectLst/>
                           <a:latin typeface="Calibri" panose="020F0502020204030204" pitchFamily="34" charset="0"/>
                         </a:rPr>
-                        <a:t>remaining faithful and supportive to someone even when things are difficult</a:t>
+                        <a:t>the reason for doing something; the aim or intention behind it</a:t>
                       </a:r>
                     </a:p>
                   </a:txBody>
@@ -19424,7 +19424,7 @@
                           </a:solidFill>
                           <a:latin typeface="XCCW Joined 4a" panose="03050602040000000000" pitchFamily="66" charset="77"/>
                         </a:rPr>
-                        <a:t>cautious</a:t>
+                        <a:t>formal</a:t>
                       </a:r>
                     </a:p>
                     <a:p>
@@ -19774,7 +19774,7 @@
             <a:pPr algn="ctr"/>
             <a:r>
               <a:rPr lang="en-GB"/>
-              <a:t>cautious</a:t>
+              <a:t>formal</a:t>
             </a:r>
           </a:p>
         </p:txBody>
@@ -20695,7 +20695,7 @@
           <a:p>
             <a:r>
               <a:rPr lang="en-US" sz="2200" dirty="0"/>
-              <a:t>Cludge did not look like a friend. He was enormous — far bigger than any creature Varjak had encountered in the city — with a coat the colour of mud and paws like small boulders. When Varjak first spotted him, every instinct told him to run: his fur bristled, his claws flexed, and his heart hammered against his ribs in a rhythm that had only one word in it. Danger. But Cludge simply sat there in the rain, blinking his enormous, slow eyes, and something in his stillness made Varjak pause. He had never expected to feel anything other than fear around a dog. He remained cautious, keeping low to the ground and watching every tiny movement, yet he did not leave. There was something in the dog’s expression — a kind of sadness, a kind of loneliness — that Varjak recognised, because he had felt it himself ever since arriving in the city. Slowly, hesitantly, he crept a little closer. It was perhaps the most unlikely friendship either of them had ever imagined. Varjak was a kitten, small and vulnerable, far from everything he had ever known. Cludge was a stray, enormous and gentle, with no one in the world. But as the rain fell quietly around them and neither of them moved away, something passed between them that neither could have named — the first, fragile thread of something that might one day become loyal and true.</a:t>
+              <a:t>Explanation texts are written to make complex processes clear to the reader. Unlike narratives, which tell a story from one moment to the next, explanation texts are organised around ideas rather than events. A writer of an explanation text must therefore make careful choices about how to structure what they want to convey. One of the most important tools available is the causal connective. Words and phrases such as ‘because’, ‘as a result’ and ‘this means that’ allow the writer to show how one thing causes or leads to another. Without these connections, the reader would be left with a list of facts that do not obviously relate to each other. Technical vocabulary is also central to the explanation text. Using precise, subject-specific words gives the writing authority and allows the writer to convey meaning efficiently. A formal tone signals to the reader that the purpose of the text is informational rather than expressive. When a writer uses the present tense and third person throughout, it creates a sense of objective, reliable fact. These features work together to serve the text’s purpose: to explain something clearly, logically and accurately. A skilled reader of explanation texts learns to recognise these features and use them to navigate the content more effectively, extracting the information they need with greater confidence.</a:t>
             </a:r>
           </a:p>
         </p:txBody>
@@ -27222,13 +27222,13 @@
           <a:p>
             <a:r>
               <a:rPr lang="en-US" sz="1900"/>
-              <a:t>How does Varjak feel when he first sees Cludge? Use evidence from the text.</a:t>
+              <a:t>Why do explanation writers use causal connectives, according to this extract?</a:t>
             </a:r>
           </a:p>
           <a:p>
             <a:r>
               <a:rPr lang="en-US" sz="1900"/>
-              <a:t>He feels afraid — his ‘fur bristled, his claws flexed, and his heart hammered’, showing his body reacted as though he was in danger.</a:t>
+              <a:t>To show how one thing causes or leads to another, so the reader can follow the reasoning clearly rather than being left with unconnected facts.</a:t>
             </a:r>
           </a:p>
           <a:p>
@@ -27237,13 +27237,13 @@
           <a:p>
             <a:r>
               <a:rPr lang="en-US" sz="1900"/>
-              <a:t>Find a word or phrase from the text that shows Varjak did not fully trust Cludge at first.</a:t>
+              <a:t>Find a phrase from the text that suggests explanation texts use a factual tone.</a:t>
             </a:r>
           </a:p>
           <a:p>
             <a:r>
               <a:rPr lang="en-US" sz="1900"/>
-              <a:t>‘He remained cautious, keeping low to the ground’ — this shows he was careful and watchful rather than relaxed.</a:t>
+              <a:t>‘Objective, reliable fact’ — this shows the writing aims to sound trustworthy and informational rather than personal or expressive.</a:t>
             </a:r>
           </a:p>
         </p:txBody>
@@ -27283,7 +27283,7 @@
           <a:p>
             <a:r>
               <a:rPr lang="en-US" sz="2200"/>
-              <a:t>Cludge did not look like a friend. He was enormous — far bigger than any creature Varjak had encountered in the city — with a coat the colour of mud and paws like small boulders. When Varjak first spotted him, every instinct told him to run: his fur bristled, his claws flexed, and his heart hammered against his ribs in a rhythm that had only one word in it. Danger. But Cludge simply sat there in the rain, blinking his enormous, slow eyes, and something in his stillness made Varjak pause. He had never expected to feel anything other than fear around a dog. He remained cautious, keeping low to the ground and watching every tiny movement, yet he did not leave. There was something in the dog’s expression — a kind of sadness, a kind of loneliness — that Varjak recognised, because he had felt it himself ever since arriving in the city. Slowly, hesitantly, he crept a little closer. It was perhaps the most unlikely friendship either of them had ever imagined. Varjak was a kitten, small and vulnerable, far from everything he had ever known. Cludge was a stray, enormous and gentle, with no one in the world. But as the rain fell quietly around them and neither of them moved away, something passed between them that neither could have named — the first, fragile thread of something that might one day become loyal and true.</a:t>
+              <a:t>Explanation texts are written to make complex processes clear to the reader. Unlike narratives, which tell a story from one moment to the next, explanation texts are organised around ideas rather than events. A writer of an explanation text must therefore make careful choices about how to structure what they want to convey. One of the most important tools available is the causal connective. Words and phrases such as ‘because’, ‘as a result’ and ‘this means that’ allow the writer to show how one thing causes or leads to another. Without these connections, the reader would be left with a list of facts that do not obviously relate to each other. Technical vocabulary is also central to the explanation text. Using precise, subject-specific words gives the writing authority and allows the writer to convey meaning efficiently. A formal tone signals to the reader that the purpose of the text is informational rather than expressive. When a writer uses the present tense and third person throughout, it creates a sense of objective, reliable fact. These features work together to serve the text’s purpose: to explain something clearly, logically and accurately. A skilled reader of explanation texts learns to recognise these features and use them to navigate the content more effectively, extracting the information they need with greater confidence.</a:t>
             </a:r>
           </a:p>
         </p:txBody>
@@ -28672,7 +28672,7 @@
                           <a:effectLst/>
                           <a:latin typeface="Calibri" panose="020F0502020204030204" pitchFamily="34" charset="0"/>
                         </a:rPr>
-                        <a:t>ancient</a:t>
+                        <a:t>navigate</a:t>
                       </a:r>
                     </a:p>
                   </a:txBody>
@@ -28731,7 +28731,7 @@
                           <a:effectLst/>
                           <a:latin typeface="Calibri" panose="020F0502020204030204" pitchFamily="34" charset="0"/>
                         </a:rPr>
-                        <a:t>very old; having existed for a very long time</a:t>
+                        <a:t>to find your way through an area; to plan and follow a route</a:t>
                       </a:r>
                     </a:p>
                   </a:txBody>
@@ -28797,7 +28797,7 @@
                           <a:effectLst/>
                           <a:latin typeface="Calibri" panose="020F0502020204030204" pitchFamily="34" charset="0"/>
                         </a:rPr>
-                        <a:t>trembling</a:t>
+                        <a:t>territory</a:t>
                       </a:r>
                     </a:p>
                   </a:txBody>
@@ -28856,7 +28856,7 @@
                           <a:effectLst/>
                           <a:latin typeface="Calibri" panose="020F0502020204030204" pitchFamily="34" charset="0"/>
                         </a:rPr>
-                        <a:t>shaking slightly because of fear, cold or strong feelings</a:t>
+                        <a:t>an area of land that an animal claims and guards as its own</a:t>
                       </a:r>
                     </a:p>
                   </a:txBody>
@@ -28922,7 +28922,7 @@
                           <a:effectLst/>
                           <a:latin typeface="Calibri" panose="020F0502020204030204" pitchFamily="34" charset="0"/>
                         </a:rPr>
-                        <a:t>persistent</a:t>
+                        <a:t>perceive</a:t>
                       </a:r>
                     </a:p>
                   </a:txBody>
@@ -28981,7 +28981,7 @@
                           <a:effectLst/>
                           <a:latin typeface="Calibri" panose="020F0502020204030204" pitchFamily="34" charset="0"/>
                         </a:rPr>
-                        <a:t>continuing to try even when something is difficult</a:t>
+                        <a:t>to notice or become aware of something using your senses</a:t>
                       </a:r>
                     </a:p>
                   </a:txBody>
@@ -29047,7 +29047,7 @@
                           <a:effectLst/>
                           <a:latin typeface="Calibri" panose="020F0502020204030204" pitchFamily="34" charset="0"/>
                         </a:rPr>
-                        <a:t>glimpse</a:t>
+                        <a:t>acute</a:t>
                       </a:r>
                     </a:p>
                   </a:txBody>
@@ -29106,7 +29106,7 @@
                           <a:effectLst/>
                           <a:latin typeface="Calibri" panose="020F0502020204030204" pitchFamily="34" charset="0"/>
                         </a:rPr>
-                        <a:t>a very quick, brief look at something</a:t>
+                        <a:t>very sharp or highly developed; much stronger than usual</a:t>
                       </a:r>
                     </a:p>
                   </a:txBody>
@@ -29172,7 +29172,7 @@
                           <a:effectLst/>
                           <a:latin typeface="Calibri" panose="020F0502020204030204" pitchFamily="34" charset="0"/>
                         </a:rPr>
-                        <a:t>stirring</a:t>
+                        <a:t>detect</a:t>
                       </a:r>
                     </a:p>
                   </a:txBody>
@@ -29231,7 +29231,7 @@
                           <a:effectLst/>
                           <a:latin typeface="Calibri" panose="020F0502020204030204" pitchFamily="34" charset="0"/>
                         </a:rPr>
-                        <a:t>beginning to move or become active; starting to feel something</a:t>
+                        <a:t>to notice or discover something, especially something hidden</a:t>
                       </a:r>
                     </a:p>
                   </a:txBody>
@@ -30318,7 +30318,7 @@
                           </a:solidFill>
                           <a:latin typeface="Twinkl Cursive Looped Light" panose="02000000000000000000" pitchFamily="2" charset="77"/>
                         </a:rPr>
-                        <a:t>persistent</a:t>
+                        <a:t>navigate</a:t>
                       </a:r>
                     </a:p>
                     <a:p>
@@ -30668,7 +30668,7 @@
             <a:pPr algn="ctr"/>
             <a:r>
               <a:rPr lang="en-GB"/>
-              <a:t>persistent</a:t>
+              <a:t>navigate</a:t>
             </a:r>
           </a:p>
         </p:txBody>
@@ -31265,7 +31265,7 @@
           <a:p>
             <a:r>
               <a:rPr lang="en-GB" sz="2200"/>
-              <a:t>In the silence of the mountain, Varjak crouched low on the cold stone and tried once again to still his mind. The Way of Jalal was ancient — older than anything his family could remember — and Varjak had always believed it was just a story that Elder Paw whispered on quiet evenings. But now, as he closed his eyes and reached inside himself for something he could not yet name, he understood that it was far more than a tale. His legs were trembling with the effort of holding the same position for so long, and sweat dampened the fine fur beneath his chin. He tried to shut out the sounds of the world: the wind moving through the grass, his grandmother’s distant voice calling across the hillside. A persistent voice in his head told him he was doing it wrong, that he was too young, too small, too ordinary to learn what the great Jalal had taught. Yet somewhere deep in his chest, something was stirring — a tiny flicker of warmth that refused to go out no matter how many times doubt tried to smother it. When he opened his eyes, he caught a glimpse of a world that looked exactly as it always had, and yet somehow felt entirely different. Whatever the Way was, it was waking up inside him, and Varjak was just beginning to understand why that mattered.</a:t>
+              <a:t>Cats are extraordinary animals with senses that allow them to navigate the world in ways that humans cannot. A cat’s eyes are particularly well suited to detecting movement in low light. The pupils can expand to an enormous size, letting in as much light as possible, which is why cats can see so clearly at night while humans must rely on artificial lighting. Their hearing is equally acute, allowing them to perceive sounds at much higher frequencies than we can. This means a cat can detect the tiny rustle of a mouse beneath a floorboard, or the distant call of another cat several streets away. Cats also use their whiskers as highly sensitive instruments for measuring space. The whiskers are exactly as wide as the cat’s body, which allows the animal to judge whether a gap is large enough to pass through. This is not something the cat has to learn; it is built into its nervous system from birth. Finally, a cat’s sense of smell is many times stronger than our own. Cats use this to map their territory, leaving chemical signals that tell other cats where they have been. Together, these extraordinary senses allow the cat to move through the world with a precision and confidence that, in many ways, puts human perception to shame.</a:t>
             </a:r>
             <a:endParaRPr lang="en-GB" sz="2200" noProof="0"/>
           </a:p>
@@ -37686,7 +37686,7 @@
             </a:pPr>
             <a:r>
               <a:rPr lang="en-GB" sz="2200"/>
-              <a:t>What is Varjak trying to do in this extract?</a:t>
+              <a:t>What is this text mainly about?</a:t>
             </a:r>
           </a:p>
           <a:p>
@@ -37697,7 +37697,7 @@
             </a:pPr>
             <a:r>
               <a:rPr lang="en-GB" sz="2200"/>
-              <a:t>He is trying to learn the Way of Jalal, an ancient skill, by staying still and focusing his mind.</a:t>
+              <a:t>It explains the senses that cats use to navigate and survive — including eyesight, hearing, whiskers and sense of smell.</a:t>
             </a:r>
           </a:p>
           <a:p>
@@ -37716,7 +37716,7 @@
             </a:pPr>
             <a:r>
               <a:rPr lang="en-GB" sz="2200"/>
-              <a:t>Find a word in the text that means ‘continuing to try even when something is difficult’.</a:t>
+              <a:t>Find a word in the text that means ‘to find your way through an area’.</a:t>
             </a:r>
           </a:p>
           <a:p>
@@ -37727,7 +37727,7 @@
             </a:pPr>
             <a:r>
               <a:rPr lang="en-GB" sz="2200"/>
-              <a:t>persistent</a:t>
+              <a:t>navigate</a:t>
             </a:r>
           </a:p>
           <a:p>
@@ -37880,7 +37880,7 @@
           <a:p>
             <a:r>
               <a:rPr lang="en-GB" sz="2200"/>
-              <a:t>In the silence of the mountain, Varjak crouched low on the cold stone and tried once again to still his mind. The Way of Jalal was ancient — older than anything his family could remember — and Varjak had always believed it was just a story that Elder Paw whispered on quiet evenings. But now, as he closed his eyes and reached inside himself for something he could not yet name, he understood that it was far more than a tale. His legs were trembling with the effort of holding the same position for so long, and sweat dampened the fine fur beneath his chin. He tried to shut out the sounds of the world: the wind moving through the grass, his grandmother’s distant voice calling across the hillside. A persistent voice in his head told him he was doing it wrong, that he was too young, too small, too ordinary to learn what the great Jalal had taught. Yet somewhere deep in his chest, something was stirring — a tiny flicker of warmth that refused to go out no matter how many times doubt tried to smother it. When he opened his eyes, he caught a glimpse of a world that looked exactly as it always had, and yet somehow felt entirely different. Whatever the Way was, it was waking up inside him, and Varjak was just beginning to understand why that mattered.</a:t>
+              <a:t>Cats are extraordinary animals with senses that allow them to navigate the world in ways that humans cannot. A cat’s eyes are particularly well suited to detecting movement in low light. The pupils can expand to an enormous size, letting in as much light as possible, which is why cats can see so clearly at night while humans must rely on artificial lighting. Their hearing is equally acute, allowing them to perceive sounds at much higher frequencies than we can. This means a cat can detect the tiny rustle of a mouse beneath a floorboard, or the distant call of another cat several streets away. Cats also use their whiskers as highly sensitive instruments for measuring space. The whiskers are exactly as wide as the cat’s body, which allows the animal to judge whether a gap is large enough to pass through. This is not something the cat has to learn; it is built into its nervous system from birth. Finally, a cat’s sense of smell is many times stronger than our own. Cats use this to map their territory, leaving chemical signals that tell other cats where they have been. Together, these extraordinary senses allow the cat to move through the world with a precision and confidence that, in many ways, puts human perception to shame.</a:t>
             </a:r>
           </a:p>
         </p:txBody>
@@ -38655,7 +38655,7 @@
             <a:pPr algn="ctr"/>
             <a:r>
               <a:rPr lang="en-GB" sz="8800" dirty="0"/>
-              <a:t>Wednesday</a:t>
+              <a:t>Thursday</a:t>
             </a:r>
           </a:p>
         </p:txBody>

</xml_diff>

<commit_message>
T6W4 Being a Reader template
</commit_message>
<xml_diff>
--- a/Reading/BeingAReader_Template.pptx
+++ b/Reading/BeingAReader_Template.pptx
@@ -6858,7 +6858,7 @@
                           <a:effectLst/>
                           <a:latin typeface="Calibri" panose="020F0502020204030204" pitchFamily="34" charset="0"/>
                         </a:rPr>
-                        <a:t>sequence</a:t>
+                        <a:t>biome</a:t>
                       </a:r>
                     </a:p>
                   </a:txBody>
@@ -6917,7 +6917,7 @@
                           <a:effectLst/>
                           <a:latin typeface="Calibri" panose="020F0502020204030204" pitchFamily="34" charset="0"/>
                         </a:rPr>
-                        <a:t>a set of events or actions that happen in a particular order</a:t>
+                        <a:t>a large natural area with its own climate, plants and animals</a:t>
                       </a:r>
                     </a:p>
                   </a:txBody>
@@ -6983,7 +6983,7 @@
                           <a:effectLst/>
                           <a:latin typeface="Calibri" panose="020F0502020204030204" pitchFamily="34" charset="0"/>
                         </a:rPr>
-                        <a:t>process</a:t>
+                        <a:t>tropical</a:t>
                       </a:r>
                     </a:p>
                   </a:txBody>
@@ -7042,7 +7042,7 @@
                           <a:effectLst/>
                           <a:latin typeface="Calibri" panose="020F0502020204030204" pitchFamily="34" charset="0"/>
                         </a:rPr>
-                        <a:t>a series of actions or steps taken to achieve a result</a:t>
+                        <a:t>relating to the warm, wet region of the Earth near the equator</a:t>
                       </a:r>
                     </a:p>
                   </a:txBody>
@@ -7108,7 +7108,7 @@
                           <a:effectLst/>
                           <a:latin typeface="Calibri" panose="020F0502020204030204" pitchFamily="34" charset="0"/>
                         </a:rPr>
-                        <a:t>adapt</a:t>
+                        <a:t>vegetation</a:t>
                       </a:r>
                     </a:p>
                   </a:txBody>
@@ -7167,7 +7167,7 @@
                           <a:effectLst/>
                           <a:latin typeface="Calibri" panose="020F0502020204030204" pitchFamily="34" charset="0"/>
                         </a:rPr>
-                        <a:t>to change in order to suit a different situation or environment</a:t>
+                        <a:t>the plants that grow in a particular area or environment</a:t>
                       </a:r>
                     </a:p>
                   </a:txBody>
@@ -7233,7 +7233,7 @@
                           <a:effectLst/>
                           <a:latin typeface="Calibri" panose="020F0502020204030204" pitchFamily="34" charset="0"/>
                         </a:rPr>
-                        <a:t>nocturnal</a:t>
+                        <a:t>topography</a:t>
                       </a:r>
                     </a:p>
                   </a:txBody>
@@ -7292,7 +7292,7 @@
                           <a:effectLst/>
                           <a:latin typeface="Calibri" panose="020F0502020204030204" pitchFamily="34" charset="0"/>
                         </a:rPr>
-                        <a:t>active mainly at night rather than during the day</a:t>
+                        <a:t>the physical features of an area of land, such as mountains, valleys and rivers</a:t>
                       </a:r>
                     </a:p>
                   </a:txBody>
@@ -7358,7 +7358,7 @@
                           <a:effectLst/>
                           <a:latin typeface="Calibri" panose="020F0502020204030204" pitchFamily="34" charset="0"/>
                         </a:rPr>
-                        <a:t>predator</a:t>
+                        <a:t>altitude</a:t>
                       </a:r>
                     </a:p>
                   </a:txBody>
@@ -7417,7 +7417,7 @@
                           <a:effectLst/>
                           <a:latin typeface="Calibri" panose="020F0502020204030204" pitchFamily="34" charset="0"/>
                         </a:rPr>
-                        <a:t>an animal that hunts and kills other animals for food</a:t>
+                        <a:t>the height of a place above sea level</a:t>
                       </a:r>
                     </a:p>
                   </a:txBody>
@@ -8497,7 +8497,7 @@
                           </a:solidFill>
                           <a:latin typeface="XCCW Joined 4a" panose="03050602040000000000" pitchFamily="66" charset="77"/>
                         </a:rPr>
-                        <a:t>adapt</a:t>
+                        <a:t>biome</a:t>
                       </a:r>
                     </a:p>
                     <a:p>
@@ -8847,7 +8847,7 @@
             <a:pPr algn="ctr"/>
             <a:r>
               <a:rPr lang="en-GB"/>
-              <a:t>adapt</a:t>
+              <a:t>biome</a:t>
             </a:r>
           </a:p>
         </p:txBody>
@@ -9511,7 +9511,7 @@
           <a:p>
             <a:r>
               <a:rPr lang="en-US" sz="2200" dirty="0"/>
-              <a:t>Unlike many animals, cats do not need to be taught most of their behaviours. A kitten is born with many responses already in place. For example, the instinct to crouch and stalk before pouncing is present almost from birth, even in kittens that have never seen prey. However, learning does play an important role in a cat’s development. A mother cat will teach her kittens how to hunt by first bringing them injured prey, then later taking them to observe while she hunts. This sequence of learning — moving from watching to copying to independent action — is a pattern found across many animal species. Cats also adapt their behaviour based on experience. A cat that has learned that a particular sound means food will respond to that sound reliably, even years later. This process of learning through repeated experience is called conditioning. Nocturnal by preference, cats are most active at dawn and dusk, when their prey is also on the move. During the day, cats conserve energy by sleeping, sometimes for up to sixteen hours. When night falls, the same cat becomes an efficient, focused predator, moving through its territory with purpose and precision. Understanding how cats learn and adapt helps us to appreciate why they behave as they do, and why domestic cats retain so many of the instincts of their wild ancestors.</a:t>
+              <a:t>Brazil is a country of extraordinary variety when it comes to its natural landscapes. The most famous of these is the Amazon rainforest, which covers more than half the country and is the world's largest tropical rainforest. This vast biome is packed with thousands of species of plants, insects and animals, many of which exist nowhere else on Earth. The Amazon receives very high amounts of rainfall throughout the year, which feeds the enormous network of rivers that flow through it, including the Amazon River itself. Beyond the rainforest, Brazil also has areas that could be described as savanna — a vast tropical grassland known in Brazil as the Cerrado. Closer to the coast, particularly in the northeast, are areas of semi-arid scrubland called the Caatinga, where rainfall is much lower and vegetation is sparse and drought-resistant. Brazil's topography is equally varied. The country has a narrow coastal strip where many of its major cities sit, including Rio de Janeiro and São Paulo. Inland, the land rises to a series of plateaus and mountain ranges, particularly in the southeast. The Amazon basin in the north and west is largely flat lowland through which the river meanders. Brazil's climate is described as tropical for most of the country, meaning it experiences warm temperatures and high rainfall for much of the year. However, different regions experience this tropical climate in different ways, and some coastal areas have different local weather patterns as a result of their position and altitude.</a:t>
             </a:r>
           </a:p>
         </p:txBody>
@@ -16038,13 +16038,13 @@
           <a:p>
             <a:r>
               <a:rPr lang="en-US" sz="1900"/>
-              <a:t>What do kittens learn from their mother, according to the text?</a:t>
+              <a:t>What is the name for Brazil's large area of tropical grassland?</a:t>
             </a:r>
           </a:p>
           <a:p>
             <a:r>
               <a:rPr lang="en-US" sz="1900"/>
-              <a:t>Kittens learn to hunt. Their mother first brings them injured prey, then lets them watch her, and finally encourages them to try alone.</a:t>
+              <a:t>It is called the Cerrado.</a:t>
             </a:r>
           </a:p>
           <a:p>
@@ -16053,13 +16053,13 @@
           <a:p>
             <a:r>
               <a:rPr lang="en-US" sz="1900"/>
-              <a:t>Find two facts from the text about how cats spend their time during the day.</a:t>
+              <a:t>Where are many of Brazil's biggest cities, such as Rio de Janeiro and São Paulo, located?</a:t>
             </a:r>
           </a:p>
           <a:p>
             <a:r>
               <a:rPr lang="en-US" sz="1900"/>
-              <a:t>Cats sleep to conserve energy — sometimes up to sixteen hours. They are most active at dawn and dusk, not during the day.</a:t>
+              <a:t>They are located on the narrow coastal strip along the east coast.</a:t>
             </a:r>
           </a:p>
         </p:txBody>
@@ -16099,7 +16099,7 @@
           <a:p>
             <a:r>
               <a:rPr lang="en-US" sz="2200"/>
-              <a:t>Unlike many animals, cats do not need to be taught most of their behaviours. A kitten is born with many responses already in place. For example, the instinct to crouch and stalk before pouncing is present almost from birth, even in kittens that have never seen prey. However, learning does play an important role in a cat’s development. A mother cat will teach her kittens how to hunt by first bringing them injured prey, then later taking them to observe while she hunts. This sequence of learning — moving from watching to copying to independent action — is a pattern found across many animal species. Cats also adapt their behaviour based on experience. A cat that has learned that a particular sound means food will respond to that sound reliably, even years later. This process of learning through repeated experience is called conditioning. Nocturnal by preference, cats are most active at dawn and dusk, when their prey is also on the move. During the day, cats conserve energy by sleeping, sometimes for up to sixteen hours. When night falls, the same cat becomes an efficient, focused predator, moving through its territory with purpose and precision. Understanding how cats learn and adapt helps us to appreciate why they behave as they do, and why domestic cats retain so many of the instincts of their wild ancestors.</a:t>
+              <a:t>Brazil is a country of extraordinary variety when it comes to its natural landscapes. The most famous of these is the Amazon rainforest, which covers more than half the country and is the world's largest tropical rainforest. This vast biome is packed with thousands of species of plants, insects and animals, many of which exist nowhere else on Earth. The Amazon receives very high amounts of rainfall throughout the year, which feeds the enormous network of rivers that flow through it, including the Amazon River itself. Beyond the rainforest, Brazil also has areas that could be described as savanna — a vast tropical grassland known in Brazil as the Cerrado. Closer to the coast, particularly in the northeast, are areas of semi-arid scrubland called the Caatinga, where rainfall is much lower and vegetation is sparse and drought-resistant. Brazil's topography is equally varied. The country has a narrow coastal strip where many of its major cities sit, including Rio de Janeiro and São Paulo. Inland, the land rises to a series of plateaus and mountain ranges, particularly in the southeast. The Amazon basin in the north and west is largely flat lowland through which the river meanders. Brazil's climate is described as tropical for most of the country, meaning it experiences warm temperatures and high rainfall for much of the year. However, different regions experience this tropical climate in different ways, and some coastal areas have different local weather patterns as a result of their position and altitude.</a:t>
             </a:r>
           </a:p>
         </p:txBody>
@@ -16745,7 +16745,7 @@
             <a:pPr algn="ctr"/>
             <a:r>
               <a:rPr lang="en-GB" sz="8800" dirty="0"/>
-              <a:t>Friday</a:t>
+              <a:t>Thursday</a:t>
             </a:r>
           </a:p>
         </p:txBody>
@@ -17785,7 +17785,7 @@
                           <a:effectLst/>
                           <a:latin typeface="Calibri" panose="020F0502020204030204" pitchFamily="34" charset="0"/>
                         </a:rPr>
-                        <a:t>formal</a:t>
+                        <a:t>commercial</a:t>
                       </a:r>
                     </a:p>
                   </a:txBody>
@@ -17844,7 +17844,7 @@
                           <a:effectLst/>
                           <a:latin typeface="Calibri" panose="020F0502020204030204" pitchFamily="34" charset="0"/>
                         </a:rPr>
-                        <a:t>following a fixed, serious style; not casual or conversational</a:t>
+                        <a:t>relating to buying, selling and business activity</a:t>
                       </a:r>
                     </a:p>
                   </a:txBody>
@@ -17910,7 +17910,7 @@
                           <a:effectLst/>
                           <a:latin typeface="Calibri" panose="020F0502020204030204" pitchFamily="34" charset="0"/>
                         </a:rPr>
-                        <a:t>technical</a:t>
+                        <a:t>residential</a:t>
                       </a:r>
                     </a:p>
                   </a:txBody>
@@ -17969,7 +17969,7 @@
                           <a:effectLst/>
                           <a:latin typeface="Calibri" panose="020F0502020204030204" pitchFamily="34" charset="0"/>
                         </a:rPr>
-                        <a:t>relating to the specific knowledge or language of a subject</a:t>
+                        <a:t>relating to an area where people live in houses or flats</a:t>
                       </a:r>
                     </a:p>
                   </a:txBody>
@@ -18035,7 +18035,7 @@
                           <a:effectLst/>
                           <a:latin typeface="Calibri" panose="020F0502020204030204" pitchFamily="34" charset="0"/>
                         </a:rPr>
-                        <a:t>causal</a:t>
+                        <a:t>agricultural</a:t>
                       </a:r>
                     </a:p>
                   </a:txBody>
@@ -18094,7 +18094,7 @@
                           <a:effectLst/>
                           <a:latin typeface="Calibri" panose="020F0502020204030204" pitchFamily="34" charset="0"/>
                         </a:rPr>
-                        <a:t>relating to or describing a cause; explaining why something happens</a:t>
+                        <a:t>relating to farming and the cultivation of land</a:t>
                       </a:r>
                     </a:p>
                   </a:txBody>
@@ -18160,7 +18160,7 @@
                           <a:effectLst/>
                           <a:latin typeface="Calibri" panose="020F0502020204030204" pitchFamily="34" charset="0"/>
                         </a:rPr>
-                        <a:t>convey</a:t>
+                        <a:t>export</a:t>
                       </a:r>
                     </a:p>
                   </a:txBody>
@@ -18219,7 +18219,7 @@
                           <a:effectLst/>
                           <a:latin typeface="Calibri" panose="020F0502020204030204" pitchFamily="34" charset="0"/>
                         </a:rPr>
-                        <a:t>to communicate an idea or meaning clearly to someone else</a:t>
+                        <a:t>to send goods to another country for sale</a:t>
                       </a:r>
                     </a:p>
                   </a:txBody>
@@ -18285,7 +18285,7 @@
                           <a:effectLst/>
                           <a:latin typeface="Calibri" panose="020F0502020204030204" pitchFamily="34" charset="0"/>
                         </a:rPr>
-                        <a:t>purpose</a:t>
+                        <a:t>economy</a:t>
                       </a:r>
                     </a:p>
                   </a:txBody>
@@ -18344,7 +18344,7 @@
                           <a:effectLst/>
                           <a:latin typeface="Calibri" panose="020F0502020204030204" pitchFamily="34" charset="0"/>
                         </a:rPr>
-                        <a:t>the reason for doing something; the aim or intention behind it</a:t>
+                        <a:t>the system by which a country produces, sells and buys goods and services</a:t>
                       </a:r>
                     </a:p>
                   </a:txBody>
@@ -19424,7 +19424,7 @@
                           </a:solidFill>
                           <a:latin typeface="XCCW Joined 4a" panose="03050602040000000000" pitchFamily="66" charset="77"/>
                         </a:rPr>
-                        <a:t>formal</a:t>
+                        <a:t>agricultural</a:t>
                       </a:r>
                     </a:p>
                     <a:p>
@@ -19774,7 +19774,7 @@
             <a:pPr algn="ctr"/>
             <a:r>
               <a:rPr lang="en-GB"/>
-              <a:t>formal</a:t>
+              <a:t>agricultural</a:t>
             </a:r>
           </a:p>
         </p:txBody>
@@ -20214,7 +20214,7 @@
             <a:pPr algn="ctr"/>
             <a:r>
               <a:rPr lang="en-GB" sz="8800" dirty="0"/>
-              <a:t>Tuesday</a:t>
+              <a:t>Monday</a:t>
             </a:r>
           </a:p>
         </p:txBody>
@@ -20695,7 +20695,7 @@
           <a:p>
             <a:r>
               <a:rPr lang="en-US" sz="2200" dirty="0"/>
-              <a:t>Explanation texts are written to make complex processes clear to the reader. Unlike narratives, which tell a story from one moment to the next, explanation texts are organised around ideas rather than events. A writer of an explanation text must therefore make careful choices about how to structure what they want to convey. One of the most important tools available is the causal connective. Words and phrases such as ‘because’, ‘as a result’ and ‘this means that’ allow the writer to show how one thing causes or leads to another. Without these connections, the reader would be left with a list of facts that do not obviously relate to each other. Technical vocabulary is also central to the explanation text. Using precise, subject-specific words gives the writing authority and allows the writer to convey meaning efficiently. A formal tone signals to the reader that the purpose of the text is informational rather than expressive. When a writer uses the present tense and third person throughout, it creates a sense of objective, reliable fact. These features work together to serve the text’s purpose: to explain something clearly, logically and accurately. A skilled reader of explanation texts learns to recognise these features and use them to navigate the content more effectively, extracting the information they need with greater confidence.</a:t>
+              <a:t>Brazil's human geography is as varied and complex as its natural landscape. The country has some of the largest cities in the world — São Paulo, for example, has a population of over 12 million people and is one of the biggest urban areas on Earth. These vast cities are a patchwork of different land uses: towering glass office blocks and commercial districts sit alongside sprawling residential suburbs, transport hubs and recreational parks. Many of Brazil's cities have grown rapidly over the past century as people have moved from rural areas to seek work in factories and businesses. Agriculture is a vital part of Brazil's economy. Huge areas of the country are given over to farmland, growing crops such as soya, sugar cane and coffee, all of which are exported to countries across the world. Brazil is one of the largest agricultural exporters on the planet, and its trade links stretch to Europe, Asia and North America. This agricultural activity has, however, led to significant clearing of natural vegetation, particularly at the edges of the Amazon rainforest. Brazil's economy has changed significantly over time. Where once it relied heavily on the export of raw materials such as rubber and coffee, it has developed a much wider range of industries, including manufacturing and technology. Despite this growth, there are large differences in wealth within Brazil — some areas are very prosperous, while others struggle with poverty. Understanding how land is used and how wealth is distributed are central questions in human geography.</a:t>
             </a:r>
           </a:p>
         </p:txBody>
@@ -27222,13 +27222,13 @@
           <a:p>
             <a:r>
               <a:rPr lang="en-US" sz="1900"/>
-              <a:t>Why do explanation writers use causal connectives, according to this extract?</a:t>
+              <a:t>Name one crop that Brazil grows and exports to other countries.</a:t>
             </a:r>
           </a:p>
           <a:p>
             <a:r>
               <a:rPr lang="en-US" sz="1900"/>
-              <a:t>To show how one thing causes or leads to another, so the reader can follow the reasoning clearly rather than being left with unconnected facts.</a:t>
+              <a:t>Any one from: soya, sugar cane or coffee.</a:t>
             </a:r>
           </a:p>
           <a:p>
@@ -27237,13 +27237,13 @@
           <a:p>
             <a:r>
               <a:rPr lang="en-US" sz="1900"/>
-              <a:t>Find a phrase from the text that suggests explanation texts use a factual tone.</a:t>
+              <a:t>What does the text suggest has happened to natural vegetation in Brazil as a result of farming?</a:t>
             </a:r>
           </a:p>
           <a:p>
             <a:r>
               <a:rPr lang="en-US" sz="1900"/>
-              <a:t>‘Objective, reliable fact’ — this shows the writing aims to sound trustworthy and informational rather than personal or expressive.</a:t>
+              <a:t>The text suggests that significant areas of natural vegetation, particularly at the edges of the Amazon rainforest, have been cleared to make way for farmland.</a:t>
             </a:r>
           </a:p>
         </p:txBody>
@@ -27283,7 +27283,7 @@
           <a:p>
             <a:r>
               <a:rPr lang="en-US" sz="2200"/>
-              <a:t>Explanation texts are written to make complex processes clear to the reader. Unlike narratives, which tell a story from one moment to the next, explanation texts are organised around ideas rather than events. A writer of an explanation text must therefore make careful choices about how to structure what they want to convey. One of the most important tools available is the causal connective. Words and phrases such as ‘because’, ‘as a result’ and ‘this means that’ allow the writer to show how one thing causes or leads to another. Without these connections, the reader would be left with a list of facts that do not obviously relate to each other. Technical vocabulary is also central to the explanation text. Using precise, subject-specific words gives the writing authority and allows the writer to convey meaning efficiently. A formal tone signals to the reader that the purpose of the text is informational rather than expressive. When a writer uses the present tense and third person throughout, it creates a sense of objective, reliable fact. These features work together to serve the text’s purpose: to explain something clearly, logically and accurately. A skilled reader of explanation texts learns to recognise these features and use them to navigate the content more effectively, extracting the information they need with greater confidence.</a:t>
+              <a:t>Brazil's human geography is as varied and complex as its natural landscape. The country has some of the largest cities in the world — São Paulo, for example, has a population of over 12 million people and is one of the biggest urban areas on Earth. These vast cities are a patchwork of different land uses: towering glass office blocks and commercial districts sit alongside sprawling residential suburbs, transport hubs and recreational parks. Many of Brazil's cities have grown rapidly over the past century as people have moved from rural areas to seek work in factories and businesses. Agriculture is a vital part of Brazil's economy. Huge areas of the country are given over to farmland, growing crops such as soya, sugar cane and coffee, all of which are exported to countries across the world. Brazil is one of the largest agricultural exporters on the planet, and its trade links stretch to Europe, Asia and North America. This agricultural activity has, however, led to significant clearing of natural vegetation, particularly at the edges of the Amazon rainforest. Brazil's economy has changed significantly over time. Where once it relied heavily on the export of raw materials such as rubber and coffee, it has developed a much wider range of industries, including manufacturing and technology. Despite this growth, there are large differences in wealth within Brazil — some areas are very prosperous, while others struggle with poverty. Understanding how land is used and how wealth is distributed are central questions in human geography.</a:t>
             </a:r>
           </a:p>
         </p:txBody>
@@ -28672,7 +28672,7 @@
                           <a:effectLst/>
                           <a:latin typeface="Calibri" panose="020F0502020204030204" pitchFamily="34" charset="0"/>
                         </a:rPr>
-                        <a:t>navigate</a:t>
+                        <a:t>hemisphere</a:t>
                       </a:r>
                     </a:p>
                   </a:txBody>
@@ -28731,7 +28731,7 @@
                           <a:effectLst/>
                           <a:latin typeface="Calibri" panose="020F0502020204030204" pitchFamily="34" charset="0"/>
                         </a:rPr>
-                        <a:t>to find your way through an area; to plan and follow a route</a:t>
+                        <a:t>one half of the Earth, divided into northern and southern or eastern and western halves</a:t>
                       </a:r>
                     </a:p>
                   </a:txBody>
@@ -28797,7 +28797,7 @@
                           <a:effectLst/>
                           <a:latin typeface="Calibri" panose="020F0502020204030204" pitchFamily="34" charset="0"/>
                         </a:rPr>
-                        <a:t>territory</a:t>
+                        <a:t>equator</a:t>
                       </a:r>
                     </a:p>
                   </a:txBody>
@@ -28856,7 +28856,7 @@
                           <a:effectLst/>
                           <a:latin typeface="Calibri" panose="020F0502020204030204" pitchFamily="34" charset="0"/>
                         </a:rPr>
-                        <a:t>an area of land that an animal claims and guards as its own</a:t>
+                        <a:t>an imaginary line around the middle of the Earth, equally distant from both poles</a:t>
                       </a:r>
                     </a:p>
                   </a:txBody>
@@ -28922,7 +28922,7 @@
                           <a:effectLst/>
                           <a:latin typeface="Calibri" panose="020F0502020204030204" pitchFamily="34" charset="0"/>
                         </a:rPr>
-                        <a:t>perceive</a:t>
+                        <a:t>latitude</a:t>
                       </a:r>
                     </a:p>
                   </a:txBody>
@@ -28981,7 +28981,7 @@
                           <a:effectLst/>
                           <a:latin typeface="Calibri" panose="020F0502020204030204" pitchFamily="34" charset="0"/>
                         </a:rPr>
-                        <a:t>to notice or become aware of something using your senses</a:t>
+                        <a:t>a measurement of how far north or south a place is from the equator</a:t>
                       </a:r>
                     </a:p>
                   </a:txBody>
@@ -29047,7 +29047,7 @@
                           <a:effectLst/>
                           <a:latin typeface="Calibri" panose="020F0502020204030204" pitchFamily="34" charset="0"/>
                         </a:rPr>
-                        <a:t>acute</a:t>
+                        <a:t>longitude</a:t>
                       </a:r>
                     </a:p>
                   </a:txBody>
@@ -29106,7 +29106,7 @@
                           <a:effectLst/>
                           <a:latin typeface="Calibri" panose="020F0502020204030204" pitchFamily="34" charset="0"/>
                         </a:rPr>
-                        <a:t>very sharp or highly developed; much stronger than usual</a:t>
+                        <a:t>a measurement of how far east or west a place is from the Prime Meridian</a:t>
                       </a:r>
                     </a:p>
                   </a:txBody>
@@ -29172,7 +29172,7 @@
                           <a:effectLst/>
                           <a:latin typeface="Calibri" panose="020F0502020204030204" pitchFamily="34" charset="0"/>
                         </a:rPr>
-                        <a:t>detect</a:t>
+                        <a:t>time zone</a:t>
                       </a:r>
                     </a:p>
                   </a:txBody>
@@ -29231,7 +29231,7 @@
                           <a:effectLst/>
                           <a:latin typeface="Calibri" panose="020F0502020204030204" pitchFamily="34" charset="0"/>
                         </a:rPr>
-                        <a:t>to notice or discover something, especially something hidden</a:t>
+                        <a:t>a region of the Earth that shares the same standard time</a:t>
                       </a:r>
                     </a:p>
                   </a:txBody>
@@ -30318,7 +30318,7 @@
                           </a:solidFill>
                           <a:latin typeface="Twinkl Cursive Looped Light" panose="02000000000000000000" pitchFamily="2" charset="77"/>
                         </a:rPr>
-                        <a:t>navigate</a:t>
+                        <a:t>hemisphere</a:t>
                       </a:r>
                     </a:p>
                     <a:p>
@@ -30668,7 +30668,7 @@
             <a:pPr algn="ctr"/>
             <a:r>
               <a:rPr lang="en-GB"/>
-              <a:t>navigate</a:t>
+              <a:t>hemisphere</a:t>
             </a:r>
           </a:p>
         </p:txBody>
@@ -31265,7 +31265,7 @@
           <a:p>
             <a:r>
               <a:rPr lang="en-GB" sz="2200"/>
-              <a:t>Cats are extraordinary animals with senses that allow them to navigate the world in ways that humans cannot. A cat’s eyes are particularly well suited to detecting movement in low light. The pupils can expand to an enormous size, letting in as much light as possible, which is why cats can see so clearly at night while humans must rely on artificial lighting. Their hearing is equally acute, allowing them to perceive sounds at much higher frequencies than we can. This means a cat can detect the tiny rustle of a mouse beneath a floorboard, or the distant call of another cat several streets away. Cats also use their whiskers as highly sensitive instruments for measuring space. The whiskers are exactly as wide as the cat’s body, which allows the animal to judge whether a gap is large enough to pass through. This is not something the cat has to learn; it is built into its nervous system from birth. Finally, a cat’s sense of smell is many times stronger than our own. Cats use this to map their territory, leaving chemical signals that tell other cats where they have been. Together, these extraordinary senses allow the cat to move through the world with a precision and confidence that, in many ways, puts human perception to shame.</a:t>
+              <a:t>Brazil is the largest country in South America and one of the biggest countries on Earth. It shares borders with almost every other country in South America, including Colombia, Bolivia, Peru and Ecuador to the west, while the Atlantic Ocean stretches along its entire eastern coast. Brazil sits in the Southern Hemisphere, which means that when it is summer in England, it is winter in Brazil. The equator runs through the very north of Brazil, which places much of the country in the tropics — the region of the globe between the Tropic of Cancer and the Tropic of Capricorn. This position gives Brazil its warm, humid climate for most of the year. Geographers use lines of latitude and longitude to pinpoint exactly where a place is on Earth. Lines of latitude run horizontally around the globe and measure how far north or south a location is from the equator. Brazil's capital, Brasília, sits at approximately 15 degrees south of the equator. Lines of longitude run vertically and measure how far east or west a place is from the Prime Meridian in Greenwich, London. Brasília lies at approximately 48 degrees west. Because Brazil is so far west of Greenwich, it operates in a different time zone. When it is noon in London, it is only 8 or 9 o'clock in the morning in Brasília, depending on the time of year. England sits in the Northern Hemisphere, in the Eastern Hemisphere, and in the temperate climate zone — making its position on the globe very different from Brazil's.</a:t>
             </a:r>
             <a:endParaRPr lang="en-GB" sz="2200" noProof="0"/>
           </a:p>
@@ -37686,7 +37686,7 @@
             </a:pPr>
             <a:r>
               <a:rPr lang="en-GB" sz="2200"/>
-              <a:t>What is this text mainly about?</a:t>
+              <a:t>Which hemisphere is Brazil mainly found in?</a:t>
             </a:r>
           </a:p>
           <a:p>
@@ -37697,7 +37697,7 @@
             </a:pPr>
             <a:r>
               <a:rPr lang="en-GB" sz="2200"/>
-              <a:t>It explains the senses that cats use to navigate and survive — including eyesight, hearing, whiskers and sense of smell.</a:t>
+              <a:t>Brazil is mainly found in the Southern Hemisphere.</a:t>
             </a:r>
           </a:p>
           <a:p>
@@ -37716,7 +37716,7 @@
             </a:pPr>
             <a:r>
               <a:rPr lang="en-GB" sz="2200"/>
-              <a:t>Find a word in the text that means ‘to find your way through an area’.</a:t>
+              <a:t>What do lines of latitude measure?</a:t>
             </a:r>
           </a:p>
           <a:p>
@@ -37727,7 +37727,7 @@
             </a:pPr>
             <a:r>
               <a:rPr lang="en-GB" sz="2200"/>
-              <a:t>navigate</a:t>
+              <a:t>Lines of latitude measure how far north or south a place is from the equator.</a:t>
             </a:r>
           </a:p>
           <a:p>
@@ -37880,7 +37880,7 @@
           <a:p>
             <a:r>
               <a:rPr lang="en-GB" sz="2200"/>
-              <a:t>Cats are extraordinary animals with senses that allow them to navigate the world in ways that humans cannot. A cat’s eyes are particularly well suited to detecting movement in low light. The pupils can expand to an enormous size, letting in as much light as possible, which is why cats can see so clearly at night while humans must rely on artificial lighting. Their hearing is equally acute, allowing them to perceive sounds at much higher frequencies than we can. This means a cat can detect the tiny rustle of a mouse beneath a floorboard, or the distant call of another cat several streets away. Cats also use their whiskers as highly sensitive instruments for measuring space. The whiskers are exactly as wide as the cat’s body, which allows the animal to judge whether a gap is large enough to pass through. This is not something the cat has to learn; it is built into its nervous system from birth. Finally, a cat’s sense of smell is many times stronger than our own. Cats use this to map their territory, leaving chemical signals that tell other cats where they have been. Together, these extraordinary senses allow the cat to move through the world with a precision and confidence that, in many ways, puts human perception to shame.</a:t>
+              <a:t>Brazil is the largest country in South America and one of the biggest countries on Earth. It shares borders with almost every other country in South America, including Colombia, Bolivia, Peru and Ecuador to the west, while the Atlantic Ocean stretches along its entire eastern coast. Brazil sits in the Southern Hemisphere, which means that when it is summer in England, it is winter in Brazil. The equator runs through the very north of Brazil, which places much of the country in the tropics — the region of the globe between the Tropic of Cancer and the Tropic of Capricorn. This position gives Brazil its warm, humid climate for most of the year. Geographers use lines of latitude and longitude to pinpoint exactly where a place is on Earth. Lines of latitude run horizontally around the globe and measure how far north or south a location is from the equator. Brazil's capital, Brasília, sits at approximately 15 degrees south of the equator. Lines of longitude run vertically and measure how far east or west a place is from the Prime Meridian in Greenwich, London. Brasília lies at approximately 48 degrees west. Because Brazil is so far west of Greenwich, it operates in a different time zone. When it is noon in London, it is only 8 or 9 o'clock in the morning in Brasília, depending on the time of year. England sits in the Northern Hemisphere, in the Eastern Hemisphere, and in the temperate climate zone — making its position on the globe very different from Brazil's.</a:t>
             </a:r>
           </a:p>
         </p:txBody>
@@ -38655,7 +38655,7 @@
             <a:pPr algn="ctr"/>
             <a:r>
               <a:rPr lang="en-GB" sz="8800" dirty="0"/>
-              <a:t>Thursday</a:t>
+              <a:t>Wednesday</a:t>
             </a:r>
           </a:p>
         </p:txBody>

</xml_diff>

<commit_message>
T6W6 Being a Reader template update
</commit_message>
<xml_diff>
--- a/Reading/BeingAReader_Template.pptx
+++ b/Reading/BeingAReader_Template.pptx
@@ -6057,7 +6057,7 @@
                 <a:latin typeface="Sassoon Infant Rg" panose="02000503030000020003" pitchFamily="2" charset="0"/>
                 <a:ea typeface="Sassoon Infant Rg" panose="02000503030000020003" pitchFamily="2" charset="0"/>
               </a:rPr>
-              <a:t>Reading makes me </a:t>
+              <a:t xml:space="preserve">Reading makes me </a:t>
             </a:r>
             <a:r>
               <a:rPr lang="en-GB" sz="3200" b="1">
@@ -6077,7 +6077,7 @@
                 <a:latin typeface="Sassoon Infant Rg" panose="02000503030000020003" pitchFamily="2" charset="0"/>
                 <a:ea typeface="Sassoon Infant Rg" panose="02000503030000020003" pitchFamily="2" charset="0"/>
               </a:rPr>
-              <a:t> because it helps me to </a:t>
+              <a:t xml:space="preserve"> because it helps me to </a:t>
             </a:r>
             <a:r>
               <a:rPr lang="en-GB" sz="3200" b="1">
@@ -6097,7 +6097,7 @@
                 <a:latin typeface="Sassoon Infant Rg" panose="02000503030000020003" pitchFamily="2" charset="0"/>
                 <a:ea typeface="Sassoon Infant Rg" panose="02000503030000020003" pitchFamily="2" charset="0"/>
               </a:rPr>
-              <a:t> the world around me.</a:t>
+              <a:t xml:space="preserve"> the world around me.</a:t>
             </a:r>
           </a:p>
         </p:txBody>
@@ -6247,7 +6247,7 @@
                 <a:latin typeface="Sassoon Infant Rg" panose="02000503030000020003" pitchFamily="2" charset="0"/>
                 <a:ea typeface="Sassoon Infant Rg" panose="02000503030000020003" pitchFamily="2" charset="0"/>
               </a:rPr>
-              <a:t>We love to read, learn to read and read to learn! </a:t>
+              <a:t xml:space="preserve">We love to read, learn to read and read to learn! </a:t>
             </a:r>
           </a:p>
         </p:txBody>
@@ -6810,7 +6810,7 @@
           <a:p>
             <a:r>
               <a:rPr lang="en-GB"/>
-              <a:t>Are there any words you feel confident to explain the meaning of (definition)? Are there any where you are less confident?</a:t>
+              <a:t>the large-scale cutting down of trees in a forested area</a:t>
             </a:r>
           </a:p>
         </p:txBody>
@@ -6923,7 +6923,7 @@
                           <a:effectLst/>
                           <a:latin typeface="Calibri" panose="020F0502020204030204" pitchFamily="34" charset="0"/>
                         </a:rPr>
-                        <a:t>biome</a:t>
+                        <a:t>deforestation</a:t>
                       </a:r>
                     </a:p>
                   </a:txBody>
@@ -6982,7 +6982,7 @@
                           <a:effectLst/>
                           <a:latin typeface="Calibri" panose="020F0502020204030204" pitchFamily="34" charset="0"/>
                         </a:rPr>
-                        <a:t>A large natural area with its own climate, plants and animals.</a:t>
+                        <a:t>using natural resources carefully so they can continue to be available in the future</a:t>
                       </a:r>
                     </a:p>
                   </a:txBody>
@@ -7048,7 +7048,7 @@
                           <a:effectLst/>
                           <a:latin typeface="Calibri" panose="020F0502020204030204" pitchFamily="34" charset="0"/>
                         </a:rPr>
-                        <a:t>topography</a:t>
+                        <a:t>sustainability</a:t>
                       </a:r>
                     </a:p>
                   </a:txBody>
@@ -7107,7 +7107,7 @@
                           <a:effectLst/>
                           <a:latin typeface="Calibri" panose="020F0502020204030204" pitchFamily="34" charset="0"/>
                         </a:rPr>
-                        <a:t>The physical features of an area of land, such as mountains, rivers and plains.</a:t>
+                        <a:t>the variety of plants and animals living in a particular area</a:t>
                       </a:r>
                     </a:p>
                   </a:txBody>
@@ -7173,7 +7173,7 @@
                           <a:effectLst/>
                           <a:latin typeface="Calibri" panose="020F0502020204030204" pitchFamily="34" charset="0"/>
                         </a:rPr>
-                        <a:t>vegetation</a:t>
+                        <a:t>biodiversity</a:t>
                       </a:r>
                     </a:p>
                   </a:txBody>
@@ -7232,7 +7232,7 @@
                           <a:effectLst/>
                           <a:latin typeface="Calibri" panose="020F0502020204030204" pitchFamily="34" charset="0"/>
                         </a:rPr>
-                        <a:t>The plants that grow in a particular area or environment.</a:t>
+                        <a:t>the protection and careful management of the natural environment</a:t>
                       </a:r>
                     </a:p>
                   </a:txBody>
@@ -7298,7 +7298,7 @@
                           <a:effectLst/>
                           <a:latin typeface="Calibri" panose="020F0502020204030204" pitchFamily="34" charset="0"/>
                         </a:rPr>
-                        <a:t>tropical</a:t>
+                        <a:t>conservation</a:t>
                       </a:r>
                     </a:p>
                   </a:txBody>
@@ -7357,7 +7357,7 @@
                           <a:effectLst/>
                           <a:latin typeface="Calibri" panose="020F0502020204030204" pitchFamily="34" charset="0"/>
                         </a:rPr>
-                        <a:t>Relating to the region near the equator, known for its warm, wet climate.</a:t>
+                        <a:t>returning land to its natural state, allowing wildlife and habitats to recover</a:t>
                       </a:r>
                     </a:p>
                   </a:txBody>
@@ -7423,7 +7423,7 @@
                           <a:effectLst/>
                           <a:latin typeface="Calibri" panose="020F0502020204030204" pitchFamily="34" charset="0"/>
                         </a:rPr>
-                        <a:t>tundra</a:t>
+                        <a:t>rewilding</a:t>
                       </a:r>
                     </a:p>
                   </a:txBody>
@@ -8562,7 +8562,7 @@
                           </a:solidFill>
                           <a:latin typeface="XCCW Joined 4a" panose="03050602040000000000" pitchFamily="66" charset="77"/>
                         </a:rPr>
-                        <a:t>biome</a:t>
+                        <a:t>sustainability</a:t>
                       </a:r>
                     </a:p>
                     <a:p>
@@ -8912,7 +8912,7 @@
             <a:pPr algn="ctr"/>
             <a:r>
               <a:rPr lang="en-GB"/>
-              <a:t>biome</a:t>
+              <a:t>sustainability</a:t>
             </a:r>
           </a:p>
         </p:txBody>
@@ -9398,7 +9398,7 @@
                 <a:ea typeface="Sassoon Infant Rg" panose="02000503030000020003" pitchFamily="2" charset="0"/>
                 <a:cs typeface="Times New Roman" panose="02020603050405020304" pitchFamily="18" charset="0"/>
               </a:rPr>
-              <a:t>Read the complete text – underline any words or phrases you don’t understand.  Re-read full sentences for any parts you couldn’t read smoothly on the first attempt. </a:t>
+              <a:t xml:space="preserve">Read the complete text – underline any words or phrases you don’t understand.  Re-read full sentences for any parts you couldn’t read smoothly on the first attempt. </a:t>
             </a:r>
             <a:endParaRPr lang="en-GB" b="1"/>
           </a:p>
@@ -9576,7 +9576,7 @@
           <a:p>
             <a:r>
               <a:rPr lang="en-US" sz="2200"/>
-              <a:t>Brazil’s physical geography is extraordinarily varied, making it one of the most diverse countries on Earth. The Amazon rainforest covers a vast portion of the interior, forming one of the world’s most important tropical biomes — a large natural area defined by its climate, vegetation and wildlife. The Amazon biome is characterised by enormous biodiversity, dense tree cover and very high rainfall throughout the year. Further south, the landscape shifts to a vast tropical grassland known as the Cerrado, which has its own distinct vegetation and wildlife. The topography of Brazil ranges from the low-lying flood plains of the Amazon basin to the highlands of the Brazilian Plateau in the south and east. The country sits within the tropical climate zone, which extends between the tropics and is known for its warm temperatures and high cloud cover. England’s physical geography is strikingly different. England has no tropical rainforest or grassland biome; instead, it is classified as a temperate deciduous woodland biome, where trees such as oak, ash and beech shed their leaves each autumn. England’s topography is mostly gentle and rolling, with its highest ground in the north, in the Lake District and the Pennines. Its climate is cool and often wet, with four distinct seasons — a sharp contrast to the largely warm and humid conditions found across Brazil.</a:t>
+              <a:t>For decades, vast stretches of the Amazon rainforest have been cleared to make way for farmland, cattle ranching and logging. At its peak in the early 2000s, Brazil was losing an area of forest the size of Belgium every year. Deforestation on this scale removes habitats for millions of species, releases stored carbon into the atmosphere and disrupts the water cycle that the entire South American continent depends upon. In recent years, Brazil has taken steps towards sustainability. The Amazon Fund, supported by Norway and Germany, has paid Brazil to reduce deforestation rates, and satellite technology is now used to monitor illegal logging. Between 2004 and 2012, Brazil cut its deforestation rate by nearly eighty percent — one of the largest conservation successes in history. However, rates rose again sharply in the late 2010s, and campaigners argue that the rainforest still faces serious threats. England faces its own sustainability challenges. Intensive farming has removed hedgerows, drained wetlands and reduced biodiversity across much of the countryside. In response, the government has introduced conservation schemes that pay farmers to restore habitats, plant trees and reduce chemical use. The Knepp Estate in West Sussex has become famous for its rewilding project, where land that was once intensively farmed has been returned to nature. Beavers, rare butterflies and turtle doves have returned to areas where they had not been seen for generations. Both Brazil and England show that protecting the natural world requires long-term commitment, political will and significant money.</a:t>
             </a:r>
           </a:p>
         </p:txBody>
@@ -16103,13 +16103,13 @@
           <a:p>
             <a:r>
               <a:rPr lang="en-US" sz="1900"/>
-              <a:t>What is a biome? Name one found in Brazil.</a:t>
+              <a:t>What does deforestation mean and why is it a problem?</a:t>
             </a:r>
           </a:p>
           <a:p>
             <a:r>
               <a:rPr lang="en-US" sz="1900"/>
-              <a:t>A biome is a large natural area with its own climate, plants and animals. The Amazon rainforest is one biome found in Brazil.</a:t>
+              <a:t>Deforestation is the large-scale cutting down of trees. It destroys habitats, releases carbon and disrupts the water cycle.</a:t>
             </a:r>
           </a:p>
           <a:p>
@@ -16118,13 +16118,13 @@
           <a:p>
             <a:r>
               <a:rPr lang="en-US" sz="1900"/>
-              <a:t>How is England's topography different from Brazil's?</a:t>
+              <a:t>Name the two countries that supported the Amazon Fund.</a:t>
             </a:r>
           </a:p>
           <a:p>
             <a:r>
               <a:rPr lang="en-US" sz="1900"/>
-              <a:t>England's topography is mostly gentle and rolling, with the highest ground in the north. Brazil's ranges from low-lying flood plains to highland plateaus, making it much more varied.</a:t>
+              <a:t>Norway and Germany.</a:t>
             </a:r>
           </a:p>
         </p:txBody>
@@ -16164,7 +16164,7 @@
           <a:p>
             <a:r>
               <a:rPr lang="en-US" sz="2200"/>
-              <a:t>Brazil’s physical geography is extraordinarily varied, making it one of the most diverse countries on Earth. The Amazon rainforest covers a vast portion of the interior, forming one of the world’s most important tropical biomes — a large natural area defined by its climate, vegetation and wildlife. The Amazon biome is characterised by enormous biodiversity, dense tree cover and very high rainfall throughout the year. Further south, the landscape shifts to a vast tropical grassland known as the Cerrado, which has its own distinct vegetation and wildlife. The topography of Brazil ranges from the low-lying flood plains of the Amazon basin to the highlands of the Brazilian Plateau in the south and east. The country sits within the tropical climate zone, which extends between the tropics and is known for its warm temperatures and high cloud cover. England’s physical geography is strikingly different. England has no tropical rainforest or grassland biome; instead, it is classified as a temperate deciduous woodland biome, where trees such as oak, ash and beech shed their leaves each autumn. England’s topography is mostly gentle and rolling, with its highest ground in the north, in the Lake District and the Pennines. Its climate is cool and often wet, with four distinct seasons — a sharp contrast to the largely warm and humid conditions found across Brazil.</a:t>
+              <a:t>For decades, vast stretches of the Amazon rainforest have been cleared to make way for farmland, cattle ranching and logging. At its peak in the early 2000s, Brazil was losing an area of forest the size of Belgium every year. Deforestation on this scale removes habitats for millions of species, releases stored carbon into the atmosphere and disrupts the water cycle that the entire South American continent depends upon. In recent years, Brazil has taken steps towards sustainability. The Amazon Fund, supported by Norway and Germany, has paid Brazil to reduce deforestation rates, and satellite technology is now used to monitor illegal logging. Between 2004 and 2012, Brazil cut its deforestation rate by nearly eighty percent — one of the largest conservation successes in history. However, rates rose again sharply in the late 2010s, and campaigners argue that the rainforest still faces serious threats. England faces its own sustainability challenges. Intensive farming has removed hedgerows, drained wetlands and reduced biodiversity across much of the countryside. In response, the government has introduced conservation schemes that pay farmers to restore habitats, plant trees and reduce chemical use. The Knepp Estate in West Sussex has become famous for its rewilding project, where land that was once intensively farmed has been returned to nature. Beavers, rare butterflies and turtle doves have returned to areas where they had not been seen for generations. Both Brazil and England show that protecting the natural world requires long-term commitment, political will and significant money.</a:t>
             </a:r>
           </a:p>
         </p:txBody>
@@ -16810,7 +16810,7 @@
             <a:pPr algn="ctr"/>
             <a:r>
               <a:rPr lang="en-GB" sz="8800"/>
-              <a:t>Thursday</a:t>
+              <a:t>Friday</a:t>
             </a:r>
           </a:p>
         </p:txBody>
@@ -16984,7 +16984,7 @@
                 <a:latin typeface="Sassoon Infant Rg" panose="02000503030000020003" pitchFamily="2" charset="0"/>
                 <a:ea typeface="Sassoon Infant Rg" panose="02000503030000020003" pitchFamily="2" charset="0"/>
               </a:rPr>
-              <a:t>Reading makes me </a:t>
+              <a:t xml:space="preserve">Reading makes me </a:t>
             </a:r>
             <a:r>
               <a:rPr lang="en-GB" sz="3200" b="1">
@@ -17004,7 +17004,7 @@
                 <a:latin typeface="Sassoon Infant Rg" panose="02000503030000020003" pitchFamily="2" charset="0"/>
                 <a:ea typeface="Sassoon Infant Rg" panose="02000503030000020003" pitchFamily="2" charset="0"/>
               </a:rPr>
-              <a:t> because it helps me to </a:t>
+              <a:t xml:space="preserve"> because it helps me to </a:t>
             </a:r>
             <a:r>
               <a:rPr lang="en-GB" sz="3200" b="1">
@@ -17024,7 +17024,7 @@
                 <a:latin typeface="Sassoon Infant Rg" panose="02000503030000020003" pitchFamily="2" charset="0"/>
                 <a:ea typeface="Sassoon Infant Rg" panose="02000503030000020003" pitchFamily="2" charset="0"/>
               </a:rPr>
-              <a:t> the world around me.</a:t>
+              <a:t xml:space="preserve"> the world around me.</a:t>
             </a:r>
           </a:p>
         </p:txBody>
@@ -17174,7 +17174,7 @@
                 <a:latin typeface="Sassoon Infant Rg" panose="02000503030000020003" pitchFamily="2" charset="0"/>
                 <a:ea typeface="Sassoon Infant Rg" panose="02000503030000020003" pitchFamily="2" charset="0"/>
               </a:rPr>
-              <a:t>We love to read, learn to read and read to learn! </a:t>
+              <a:t xml:space="preserve">We love to read, learn to read and read to learn! </a:t>
             </a:r>
           </a:p>
         </p:txBody>
@@ -17737,7 +17737,7 @@
           <a:p>
             <a:r>
               <a:rPr lang="en-GB"/>
-              <a:t>Are there any words you feel confident to explain the meaning of (definition)? Are there any where you are less confident?</a:t>
+              <a:t>the moment when a small change triggers a larger, often irreversible change</a:t>
             </a:r>
           </a:p>
         </p:txBody>
@@ -17850,7 +17850,7 @@
                           <a:effectLst/>
                           <a:latin typeface="Calibri" panose="020F0502020204030204" pitchFamily="34" charset="0"/>
                         </a:rPr>
-                        <a:t>economy</a:t>
+                        <a:t>tipping point</a:t>
                       </a:r>
                     </a:p>
                   </a:txBody>
@@ -17909,7 +17909,7 @@
                           <a:effectLst/>
                           <a:latin typeface="Calibri" panose="020F0502020204030204" pitchFamily="34" charset="0"/>
                         </a:rPr>
-                        <a:t>The system by which a country produces, distributes and uses money, goods and services.</a:t>
+                        <a:t>gases such as carbon dioxide released into the atmosphere, usually from burning fuels</a:t>
                       </a:r>
                     </a:p>
                   </a:txBody>
@@ -17975,7 +17975,7 @@
                           <a:effectLst/>
                           <a:latin typeface="Calibri" panose="020F0502020204030204" pitchFamily="34" charset="0"/>
                         </a:rPr>
-                        <a:t>trade</a:t>
+                        <a:t>emissions</a:t>
                       </a:r>
                     </a:p>
                   </a:txBody>
@@ -18034,7 +18034,7 @@
                           <a:effectLst/>
                           <a:latin typeface="Calibri" panose="020F0502020204030204" pitchFamily="34" charset="0"/>
                         </a:rPr>
-                        <a:t>The activity of buying and selling goods between people or countries.</a:t>
+                        <a:t>the point at which the amount of greenhouse gases added equals the amount removed</a:t>
                       </a:r>
                     </a:p>
                   </a:txBody>
@@ -18100,7 +18100,7 @@
                           <a:effectLst/>
                           <a:latin typeface="Calibri" panose="020F0502020204030204" pitchFamily="34" charset="0"/>
                         </a:rPr>
-                        <a:t>residential</a:t>
+                        <a:t>net zero</a:t>
                       </a:r>
                     </a:p>
                   </a:txBody>
@@ -18159,7 +18159,7 @@
                           <a:effectLst/>
                           <a:latin typeface="Calibri" panose="020F0502020204030204" pitchFamily="34" charset="0"/>
                         </a:rPr>
-                        <a:t>Used for people to live in, such as houses and flats.</a:t>
+                        <a:t>a long period of very low rainfall leading to water shortages</a:t>
                       </a:r>
                     </a:p>
                   </a:txBody>
@@ -18225,7 +18225,7 @@
                           <a:effectLst/>
                           <a:latin typeface="Calibri" panose="020F0502020204030204" pitchFamily="34" charset="0"/>
                         </a:rPr>
-                        <a:t>agricultural</a:t>
+                        <a:t>drought</a:t>
                       </a:r>
                     </a:p>
                   </a:txBody>
@@ -18284,7 +18284,7 @@
                           <a:effectLst/>
                           <a:latin typeface="Calibri" panose="020F0502020204030204" pitchFamily="34" charset="0"/>
                         </a:rPr>
-                        <a:t>Relating to farming and the growing of crops or rearing of animals.</a:t>
+                        <a:t>a sudden, large rise in sea level caused by storms or weather systems</a:t>
                       </a:r>
                     </a:p>
                   </a:txBody>
@@ -18350,7 +18350,7 @@
                           <a:effectLst/>
                           <a:latin typeface="Calibri" panose="020F0502020204030204" pitchFamily="34" charset="0"/>
                         </a:rPr>
-                        <a:t>commercial</a:t>
+                        <a:t>tidal surge</a:t>
                       </a:r>
                     </a:p>
                   </a:txBody>
@@ -19489,7 +19489,7 @@
                           </a:solidFill>
                           <a:latin typeface="XCCW Joined 4a" panose="03050602040000000000" pitchFamily="66" charset="77"/>
                         </a:rPr>
-                        <a:t>economy</a:t>
+                        <a:t>emissions</a:t>
                       </a:r>
                     </a:p>
                     <a:p>
@@ -19839,7 +19839,7 @@
             <a:pPr algn="ctr"/>
             <a:r>
               <a:rPr lang="en-GB"/>
-              <a:t>economy</a:t>
+              <a:t>emissions</a:t>
             </a:r>
           </a:p>
         </p:txBody>
@@ -20582,7 +20582,7 @@
                 <a:ea typeface="Sassoon Infant Rg" panose="02000503030000020003" pitchFamily="2" charset="0"/>
                 <a:cs typeface="Times New Roman" panose="02020603050405020304" pitchFamily="18" charset="0"/>
               </a:rPr>
-              <a:t>Read the complete text – underline any words or phrases you don’t understand.  Re-read full sentences for any parts you couldn’t read smoothly on the first attempt. </a:t>
+              <a:t xml:space="preserve">Read the complete text – underline any words or phrases you don’t understand.  Re-read full sentences for any parts you couldn’t read smoothly on the first attempt. </a:t>
             </a:r>
             <a:endParaRPr lang="en-GB" b="1"/>
           </a:p>
@@ -20760,7 +20760,7 @@
           <a:p>
             <a:r>
               <a:rPr lang="en-US" sz="2200"/>
-              <a:t>Brazil and England share some similarities in the way they use their land, but the differences are significant. In England, land is divided between residential areas where people live, commercial zones full of shops and offices, and agricultural land used for growing crops and raising animals. Transport networks such as roads, railways and airports connect these areas efficiently. In Brazil, land use patterns are more complex and dramatic in scale. Vast areas of the interior are used for agriculture, particularly for growing soya beans and rearing cattle, which are among Brazil’s most important exports. Brazil is one of the world’s leading agricultural producers, and its economy relies heavily on trade with other countries. It exports iron ore, oil, coffee and meat to nations across the globe, including to the United Kingdom. However, rapid growth in agriculture has put pressure on the Amazon rainforest, as forested land has been cleared to make way for farms. In England, economic activity is spread more evenly between industry, services and trade. England’s cities contain large commercial zones, and the economy is heavily focused on services such as banking, retail and education. Both countries are part of a global trading network, but the scale, the challenges and the opportunities they face are very different — a reflection of their contrasting size, climate and resources.</a:t>
+              <a:t>Climate change is already reshaping life in both Brazil and England, though in very different ways. In Brazil, rising temperatures have worsened droughts in the northeast, where communities that depend on river water for farming and drinking are finding rivers running lower than at any point in living memory. In the Amazon, scientists have found that some parts of the forest are now releasing more carbon than they absorb, a warning sign that one of the world's most important carbon stores may be approaching a tipping point. England's challenges look different but are no less serious. Winters are becoming wetter and summers hotter. Flooding has hit communities in Somerset, Yorkshire and Gloucestershire repeatedly in recent years, damaging homes and farmland. The Thames Barrier, built in 1982 to protect London from tidal surges, now closes far more frequently than its designers expected. Sea levels are rising, and low-lying coastal areas like East Anglia face an uncertain future. Both governments have made pledges. Brazil committed to ending illegal deforestation by 2030 under the Glasgow Climate Pact. The UK has set a legally binding target to reach net zero carbon emissions by 2050. But critics of both countries argue that promises on paper are not the same as action on the ground, and that for communities already feeling the effects — whether in the drought-stricken northeast of Brazil or a flooded village in Yorkshire — the pace of change is far too slow.</a:t>
             </a:r>
           </a:p>
         </p:txBody>
@@ -27287,13 +27287,13 @@
           <a:p>
             <a:r>
               <a:rPr lang="en-US" sz="1900"/>
-              <a:t>What products does Brazil export?</a:t>
+              <a:t>What are scientists worried about regarding the Amazon?</a:t>
             </a:r>
           </a:p>
           <a:p>
             <a:r>
               <a:rPr lang="en-US" sz="1900"/>
-              <a:t>Brazil exports soya beans, cattle, iron ore, oil, coffee and meat to countries around the world, including to the United Kingdom.</a:t>
+              <a:t>Parts of the Amazon are now releasing more carbon than they absorb, meaning it may be losing its ability to act as a carbon store.</a:t>
             </a:r>
           </a:p>
           <a:p>
@@ -27302,13 +27302,13 @@
           <a:p>
             <a:r>
               <a:rPr lang="en-US" sz="1900"/>
-              <a:t>Why has the Amazon rainforest been affected by farming?</a:t>
+              <a:t>Name one way that climate change is affecting England.</a:t>
             </a:r>
           </a:p>
           <a:p>
             <a:r>
               <a:rPr lang="en-US" sz="1900"/>
-              <a:t>As Brazil's agricultural industry has grown, forested land has been cleared to make way for farms, reducing the size of the rainforest.</a:t>
+              <a:t>Winters are becoming wetter, summers are hotter, and flooding has damaged homes and farmland (accept any one).</a:t>
             </a:r>
           </a:p>
         </p:txBody>
@@ -27348,7 +27348,7 @@
           <a:p>
             <a:r>
               <a:rPr lang="en-US" sz="2200"/>
-              <a:t>Brazil and England share some similarities in the way they use their land, but the differences are significant. In England, land is divided between residential areas where people live, commercial zones full of shops and offices, and agricultural land used for growing crops and raising animals. Transport networks such as roads, railways and airports connect these areas efficiently. In Brazil, land use patterns are more complex and dramatic in scale. Vast areas of the interior are used for agriculture, particularly for growing soya beans and rearing cattle, which are among Brazil’s most important exports. Brazil is one of the world’s leading agricultural producers, and its economy relies heavily on trade with other countries. It exports iron ore, oil, coffee and meat to nations across the globe, including to the United Kingdom. However, rapid growth in agriculture has put pressure on the Amazon rainforest, as forested land has been cleared to make way for farms. In England, economic activity is spread more evenly between industry, services and trade. England’s cities contain large commercial zones, and the economy is heavily focused on services such as banking, retail and education. Both countries are part of a global trading network, but the scale, the challenges and the opportunities they face are very different — a reflection of their contrasting size, climate and resources.</a:t>
+              <a:t>Climate change is already reshaping life in both Brazil and England, though in very different ways. In Brazil, rising temperatures have worsened droughts in the northeast, where communities that depend on river water for farming and drinking are finding rivers running lower than at any point in living memory. In the Amazon, scientists have found that some parts of the forest are now releasing more carbon than they absorb, a warning sign that one of the world's most important carbon stores may be approaching a tipping point. England's challenges look different but are no less serious. Winters are becoming wetter and summers hotter. Flooding has hit communities in Somerset, Yorkshire and Gloucestershire repeatedly in recent years, damaging homes and farmland. The Thames Barrier, built in 1982 to protect London from tidal surges, now closes far more frequently than its designers expected. Sea levels are rising, and low-lying coastal areas like East Anglia face an uncertain future. Both governments have made pledges. Brazil committed to ending illegal deforestation by 2030 under the Glasgow Climate Pact. The UK has set a legally binding target to reach net zero carbon emissions by 2050. But critics of both countries argue that promises on paper are not the same as action on the ground, and that for communities already feeling the effects — whether in the drought-stricken northeast of Brazil or a flooded village in Yorkshire — the pace of change is far too slow.</a:t>
             </a:r>
           </a:p>
         </p:txBody>
@@ -27916,7 +27916,7 @@
                 <a:latin typeface="Sassoon Infant Rg" panose="02000503030000020003" pitchFamily="2" charset="0"/>
                 <a:ea typeface="Sassoon Infant Rg" panose="02000503030000020003" pitchFamily="2" charset="0"/>
               </a:rPr>
-              <a:t>Reading makes me </a:t>
+              <a:t xml:space="preserve">Reading makes me </a:t>
             </a:r>
             <a:r>
               <a:rPr lang="en-GB" sz="3200" b="1">
@@ -27936,7 +27936,7 @@
                 <a:latin typeface="Sassoon Infant Rg" panose="02000503030000020003" pitchFamily="2" charset="0"/>
                 <a:ea typeface="Sassoon Infant Rg" panose="02000503030000020003" pitchFamily="2" charset="0"/>
               </a:rPr>
-              <a:t> because it helps me to </a:t>
+              <a:t xml:space="preserve"> because it helps me to </a:t>
             </a:r>
             <a:r>
               <a:rPr lang="en-GB" sz="3200" b="1">
@@ -27956,7 +27956,7 @@
                 <a:latin typeface="Sassoon Infant Rg" panose="02000503030000020003" pitchFamily="2" charset="0"/>
                 <a:ea typeface="Sassoon Infant Rg" panose="02000503030000020003" pitchFamily="2" charset="0"/>
               </a:rPr>
-              <a:t> the world around me.</a:t>
+              <a:t xml:space="preserve"> the world around me.</a:t>
             </a:r>
           </a:p>
         </p:txBody>
@@ -28106,7 +28106,7 @@
                 <a:latin typeface="Sassoon Infant Rg" panose="02000503030000020003" pitchFamily="2" charset="0"/>
                 <a:ea typeface="Sassoon Infant Rg" panose="02000503030000020003" pitchFamily="2" charset="0"/>
               </a:rPr>
-              <a:t>We love to read, learn to read and read to learn! </a:t>
+              <a:t xml:space="preserve">We love to read, learn to read and read to learn! </a:t>
             </a:r>
           </a:p>
         </p:txBody>
@@ -28737,7 +28737,7 @@
                           <a:effectLst/>
                           <a:latin typeface="Calibri" panose="020F0502020204030204" pitchFamily="34" charset="0"/>
                         </a:rPr>
-                        <a:t>hemisphere</a:t>
+                        <a:t>heritage</a:t>
                       </a:r>
                     </a:p>
                   </a:txBody>
@@ -28796,7 +28796,7 @@
                           <a:effectLst/>
                           <a:latin typeface="Calibri" panose="020F0502020204030204" pitchFamily="34" charset="0"/>
                         </a:rPr>
-                        <a:t>One of the two halves of the Earth, divided by the equator into north and south.</a:t>
+                        <a:t>the traditions, values and customs passed down through generations</a:t>
                       </a:r>
                     </a:p>
                   </a:txBody>
@@ -28862,7 +28862,7 @@
                           <a:effectLst/>
                           <a:latin typeface="Calibri" panose="020F0502020204030204" pitchFamily="34" charset="0"/>
                         </a:rPr>
-                        <a:t>latitude</a:t>
+                        <a:t>indigenous</a:t>
                       </a:r>
                     </a:p>
                   </a:txBody>
@@ -28921,7 +28921,7 @@
                           <a:effectLst/>
                           <a:latin typeface="Calibri" panose="020F0502020204030204" pitchFamily="34" charset="0"/>
                         </a:rPr>
-                        <a:t>Imaginary lines that run east to west around the Earth, measuring distance from the equator.</a:t>
+                        <a:t>originally from a place, before settlers or colonisers arrived</a:t>
                       </a:r>
                     </a:p>
                   </a:txBody>
@@ -28987,7 +28987,7 @@
                           <a:effectLst/>
                           <a:latin typeface="Calibri" panose="020F0502020204030204" pitchFamily="34" charset="0"/>
                         </a:rPr>
-                        <a:t>longitude</a:t>
+                        <a:t>dialect</a:t>
                       </a:r>
                     </a:p>
                   </a:txBody>
@@ -29046,7 +29046,7 @@
                           <a:effectLst/>
                           <a:latin typeface="Calibri" panose="020F0502020204030204" pitchFamily="34" charset="0"/>
                         </a:rPr>
-                        <a:t>Imaginary lines that run north to south on the Earth, measuring distance from Greenwich.</a:t>
+                        <a:t>a form of a language spoken in a particular area or by a particular group</a:t>
                       </a:r>
                     </a:p>
                   </a:txBody>
@@ -29112,7 +29112,7 @@
                           <a:effectLst/>
                           <a:latin typeface="Calibri" panose="020F0502020204030204" pitchFamily="34" charset="0"/>
                         </a:rPr>
-                        <a:t>equator</a:t>
+                        <a:t>diverse</a:t>
                       </a:r>
                     </a:p>
                   </a:txBody>
@@ -29171,7 +29171,7 @@
                           <a:effectLst/>
                           <a:latin typeface="Calibri" panose="020F0502020204030204" pitchFamily="34" charset="0"/>
                         </a:rPr>
-                        <a:t>The imaginary line that runs around the middle of the Earth, dividing it into north and south.</a:t>
+                        <a:t>made up of many different types of people, ideas or things</a:t>
                       </a:r>
                     </a:p>
                   </a:txBody>
@@ -29237,7 +29237,7 @@
                           <a:effectLst/>
                           <a:latin typeface="Calibri" panose="020F0502020204030204" pitchFamily="34" charset="0"/>
                         </a:rPr>
-                        <a:t>time zone</a:t>
+                        <a:t>Carnival</a:t>
                       </a:r>
                     </a:p>
                   </a:txBody>
@@ -29296,7 +29296,7 @@
                           <a:effectLst/>
                           <a:latin typeface="Calibri" panose="020F0502020204030204" pitchFamily="34" charset="0"/>
                         </a:rPr>
-                        <a:t>A region of the Earth that shares the same standard time.</a:t>
+                        <a:t>a large annual festival involving music, dancing and colourful costumes</a:t>
                       </a:r>
                     </a:p>
                   </a:txBody>
@@ -30434,7 +30434,7 @@
                           </a:solidFill>
                           <a:latin typeface="Twinkl Cursive Looped Light" panose="02000000000000000000" pitchFamily="2" charset="77"/>
                         </a:rPr>
-                        <a:t>hemisphere</a:t>
+                        <a:t>heritage</a:t>
                       </a:r>
                     </a:p>
                     <a:p>
@@ -30784,7 +30784,7 @@
             <a:pPr algn="ctr"/>
             <a:r>
               <a:rPr lang="en-GB"/>
-              <a:t>hemisphere</a:t>
+              <a:t>heritage</a:t>
             </a:r>
           </a:p>
         </p:txBody>
@@ -31136,7 +31136,7 @@
                 <a:ea typeface="Sassoon Infant Rg" panose="02000503030000020003" pitchFamily="2" charset="0"/>
                 <a:cs typeface="Times New Roman" panose="02020603050405020304" pitchFamily="18" charset="0"/>
               </a:rPr>
-              <a:t>.  </a:t>
+              <a:t xml:space="preserve">.  </a:t>
             </a:r>
             <a:r>
               <a:rPr lang="en-GB" sz="1800">
@@ -31381,7 +31381,7 @@
           <a:p>
             <a:r>
               <a:rPr lang="en-GB" sz="2200"/>
-              <a:t>Brazil is the largest country in South America, covering nearly half of the entire continent. It stretches across a wide range of latitudes and longitudes, sitting mainly in the southern hemisphere, though its most northerly regions reach across the equator into the northern hemisphere. This matters because the equator is the imaginary line that divides the Earth into two equal halves, and countries close to it receive the most direct sunlight throughout the year. Brazil shares borders with almost every other country in South America, including Colombia, Ecuador, Bolivia, Peru and Chile. England, by contrast, sits in the northern hemisphere at a latitude of roughly 50°N to 55°N, meaning it receives far less direct sunlight and enjoys a mild, temperate climate rather than a tropical one. Because Brazil and England are on different sides of the globe, they also fall into different time zones. Time zones are regions of the Earth that share the same standard time, and they are measured in relation to Greenwich Mean Time, or GMT. GMT is calculated from the Prime Meridian, which runs through the Royal Observatory in Greenwich, London. Brazil is typically between three and five hours behind GMT, depending on which part of the country you are in. When pupils in England are sitting down for lunch, children in São Paulo are only just starting their school morning.</a:t>
+              <a:t>Brazil is one of the most culturally diverse countries in the world. Its people speak Portuguese, which arrived with European settlers in the 1500s, but hundreds of indigenous languages are still spoken by communities across the Amazon basin. Over centuries, Brazil welcomed waves of immigrants from Africa, Japan, Italy, Germany and Lebanon, each bringing their own customs, food and traditions. This extraordinary blend of heritage has shaped modern Brazilian culture into something vivid and unlike anywhere else on Earth. England, too, has been shaped by the movement of people. Latin, French, Norse and Saxon languages all left their mark on English, which today borrows from more languages than almost any other tongue on the planet. Festivals like Diwali, Eid and Chinese New Year are celebrated in English cities alongside traditions that have existed for centuries. Though England is a far smaller country than Brazil, it holds a rich patchwork of local dialects, accents and customs — a Geordie from Newcastle speaks very differently to someone from Bristol. Culture is not fixed. In both countries, it changes and grows as communities share food, music, language and ideas. In Brazil, Carnival — the enormous annual festival of music, dance and costume — draws people from every region and background together in a great, joyful spectacle. In England, summer fetes, bonfire night and football bind communities in their own quieter ways. Despite the differences in scale, language and geography, both nations show that culture is always alive and always moving.</a:t>
             </a:r>
             <a:endParaRPr lang="en-GB" sz="2200" noProof="0"/>
           </a:p>
@@ -37853,7 +37853,7 @@
             </a:pPr>
             <a:r>
               <a:rPr lang="en-GB" sz="2200"/>
-              <a:t>What is the equator, and why does its position matter for a country's climate?</a:t>
+              <a:t>What language do most people in Brazil speak, and where did it come from?</a:t>
             </a:r>
           </a:p>
           <a:p>
@@ -37864,7 +37864,7 @@
             </a:pPr>
             <a:r>
               <a:rPr lang="en-GB" sz="2200"/>
-              <a:t>The equator is an imaginary line dividing the Earth into north and south. Countries near it receive more direct sunlight, so they have warmer, tropical climates.</a:t>
+              <a:t>Portuguese, which arrived with European settlers in the 1500s.</a:t>
             </a:r>
           </a:p>
           <a:p>
@@ -37883,7 +37883,7 @@
             </a:pPr>
             <a:r>
               <a:rPr lang="en-GB" sz="2200"/>
-              <a:t>Brazil is mainly in the southern hemisphere. What does this mean?</a:t>
+              <a:t>What does 'heritage' mean?</a:t>
             </a:r>
           </a:p>
           <a:p>
@@ -37894,7 +37894,7 @@
             </a:pPr>
             <a:r>
               <a:rPr lang="en-GB" sz="2200"/>
-              <a:t>It means that most of Brazil is below the equator, in the southern half of the Earth.</a:t>
+              <a:t>The traditions, values and customs passed down through generations.</a:t>
             </a:r>
           </a:p>
           <a:p>
@@ -38047,7 +38047,7 @@
           <a:p>
             <a:r>
               <a:rPr lang="en-GB" sz="2200"/>
-              <a:t>Brazil is the largest country in South America, covering nearly half of the entire continent. It stretches across a wide range of latitudes and longitudes, sitting mainly in the southern hemisphere, though its most northerly regions reach across the equator into the northern hemisphere. This matters because the equator is the imaginary line that divides the Earth into two equal halves, and countries close to it receive the most direct sunlight throughout the year. Brazil shares borders with almost every other country in South America, including Colombia, Ecuador, Bolivia, Peru and Chile. England, by contrast, sits in the northern hemisphere at a latitude of roughly 50°N to 55°N, meaning it receives far less direct sunlight and enjoys a mild, temperate climate rather than a tropical one. Because Brazil and England are on different sides of the globe, they also fall into different time zones. Time zones are regions of the Earth that share the same standard time, and they are measured in relation to Greenwich Mean Time, or GMT. GMT is calculated from the Prime Meridian, which runs through the Royal Observatory in Greenwich, London. Brazil is typically between three and five hours behind GMT, depending on which part of the country you are in. When pupils in England are sitting down for lunch, children in São Paulo are only just starting their school morning.</a:t>
+              <a:t>Brazil is one of the most culturally diverse countries in the world. Its people speak Portuguese, which arrived with European settlers in the 1500s, but hundreds of indigenous languages are still spoken by communities across the Amazon basin. Over centuries, Brazil welcomed waves of immigrants from Africa, Japan, Italy, Germany and Lebanon, each bringing their own customs, food and traditions. This extraordinary blend of heritage has shaped modern Brazilian culture into something vivid and unlike anywhere else on Earth. England, too, has been shaped by the movement of people. Latin, French, Norse and Saxon languages all left their mark on English, which today borrows from more languages than almost any other tongue on the planet. Festivals like Diwali, Eid and Chinese New Year are celebrated in English cities alongside traditions that have existed for centuries. Though England is a far smaller country than Brazil, it holds a rich patchwork of local dialects, accents and customs — a Geordie from Newcastle speaks very differently to someone from Bristol. Culture is not fixed. In both countries, it changes and grows as communities share food, music, language and ideas. In Brazil, Carnival — the enormous annual festival of music, dance and costume — draws people from every region and background together in a great, joyful spectacle. In England, summer fetes, bonfire night and football bind communities in their own quieter ways. Despite the differences in scale, language and geography, both nations show that culture is always alive and always moving.</a:t>
             </a:r>
           </a:p>
         </p:txBody>

</xml_diff>